<commit_message>
Thu Oct 22 14:16
</commit_message>
<xml_diff>
--- a/nonnormal_data_lm.pptx
+++ b/nonnormal_data_lm.pptx
@@ -5,7 +5,7 @@
     <p:sldMasterId id="2147483660" r:id="rId1"/>
   </p:sldMasterIdLst>
   <p:notesMasterIdLst>
-    <p:notesMasterId r:id="rId16"/>
+    <p:notesMasterId r:id="rId17"/>
   </p:notesMasterIdLst>
   <p:sldIdLst>
     <p:sldId id="256" r:id="rId2"/>
@@ -19,9 +19,10 @@
     <p:sldId id="264" r:id="rId10"/>
     <p:sldId id="265" r:id="rId11"/>
     <p:sldId id="266" r:id="rId12"/>
-    <p:sldId id="268" r:id="rId13"/>
-    <p:sldId id="269" r:id="rId14"/>
-    <p:sldId id="267" r:id="rId15"/>
+    <p:sldId id="270" r:id="rId13"/>
+    <p:sldId id="268" r:id="rId14"/>
+    <p:sldId id="269" r:id="rId15"/>
+    <p:sldId id="267" r:id="rId16"/>
   </p:sldIdLst>
   <p:sldSz cx="12192000" cy="6858000"/>
   <p:notesSz cx="6858000" cy="9144000"/>
@@ -120,6 +121,11 @@
       </a:defRPr>
     </a:lvl9pPr>
   </p:defaultTextStyle>
+  <p:extLst>
+    <p:ext uri="{EFAFB233-063F-42B5-8137-9DF3F51BA10A}">
+      <p15:sldGuideLst xmlns:p15="http://schemas.microsoft.com/office/powerpoint/2012/main"/>
+    </p:ext>
+  </p:extLst>
 </p:presentation>
 </file>
 
@@ -1965,7 +1971,7 @@
 <dgm:dataModel xmlns:dgm="http://schemas.openxmlformats.org/drawingml/2006/diagram" xmlns:a="http://schemas.openxmlformats.org/drawingml/2006/main">
   <dgm:ptLst>
     <dgm:pt modelId="{4BEE8537-3A9F-4D93-AAF8-BF7B064184B6}" type="doc">
-      <dgm:prSet loTypeId="urn:microsoft.com/office/officeart/2016/7/layout/BasicLinearProcessNumbered" loCatId="process" qsTypeId="urn:microsoft.com/office/officeart/2005/8/quickstyle/simple4" qsCatId="simple" csTypeId="urn:microsoft.com/office/officeart/2005/8/colors/colorful1" csCatId="colorful" phldr="1"/>
+      <dgm:prSet loTypeId="urn:microsoft.com/office/officeart/2016/7/layout/BasicLinearProcessNumbered#2" loCatId="process" qsTypeId="urn:microsoft.com/office/officeart/2005/8/quickstyle/simple4" qsCatId="simple" csTypeId="urn:microsoft.com/office/officeart/2005/8/colors/colorful1" csCatId="colorful" phldr="1"/>
       <dgm:spPr/>
       <dgm:t>
         <a:bodyPr/>
@@ -2290,46 +2296,46 @@
     </dgm:pt>
   </dgm:ptLst>
   <dgm:cxnLst>
-    <dgm:cxn modelId="{08E1D010-6A2F-934F-A3AA-27F7A736BFCD}" type="presOf" srcId="{C78368A8-9612-45FF-BF42-5DF1B05E3437}" destId="{A401024C-857A-3742-92F7-DDC5FF8C9A6D}" srcOrd="0" destOrd="0" presId="urn:microsoft.com/office/officeart/2016/7/layout/BasicLinearProcessNumbered"/>
-    <dgm:cxn modelId="{C7A94612-31A8-4A43-867E-83B36AB575C4}" type="presOf" srcId="{49F26AC4-9B33-4631-9B8C-92FA64733C20}" destId="{47586F9C-9B54-EB4F-96C8-9783A5315693}" srcOrd="1" destOrd="0" presId="urn:microsoft.com/office/officeart/2016/7/layout/BasicLinearProcessNumbered"/>
-    <dgm:cxn modelId="{64BD271C-EDB3-9746-9F45-94DC0380D1C2}" type="presOf" srcId="{13C41905-E70A-2042-A000-B6D5BD2E9B3B}" destId="{27D11AC7-A0F6-A941-9745-7807865620AC}" srcOrd="0" destOrd="0" presId="urn:microsoft.com/office/officeart/2016/7/layout/BasicLinearProcessNumbered"/>
-    <dgm:cxn modelId="{D723361D-8E51-D041-B13D-382EF8CE38F4}" type="presOf" srcId="{B4A55DA0-D537-4F9A-A96A-206D950DE888}" destId="{8D352ACD-39F3-5746-B1C6-5768095E015B}" srcOrd="1" destOrd="0" presId="urn:microsoft.com/office/officeart/2016/7/layout/BasicLinearProcessNumbered"/>
-    <dgm:cxn modelId="{248AB33B-594D-A148-B525-9331469110A1}" type="presOf" srcId="{51B20956-D3F7-4822-BDF5-C5FC17434A52}" destId="{67609B28-8CEB-5E4B-B846-D3954DE0827C}" srcOrd="1" destOrd="0" presId="urn:microsoft.com/office/officeart/2016/7/layout/BasicLinearProcessNumbered"/>
-    <dgm:cxn modelId="{4DC53A3F-7AD0-4941-A3A9-E59C444470CD}" type="presOf" srcId="{B4A55DA0-D537-4F9A-A96A-206D950DE888}" destId="{F5531E6B-EE7E-C940-BBFC-AEA2CB55A651}" srcOrd="0" destOrd="0" presId="urn:microsoft.com/office/officeart/2016/7/layout/BasicLinearProcessNumbered"/>
-    <dgm:cxn modelId="{5CB7244A-8D15-6344-95ED-96F24678AC89}" type="presOf" srcId="{00EC4378-1CE3-2D4D-99C0-FBA948CA3A04}" destId="{F98F7200-0AA2-524B-8D77-69243813A5FA}" srcOrd="0" destOrd="0" presId="urn:microsoft.com/office/officeart/2016/7/layout/BasicLinearProcessNumbered"/>
-    <dgm:cxn modelId="{8C1D9580-0EB2-2544-83DE-6C4C15D05819}" type="presOf" srcId="{13C41905-E70A-2042-A000-B6D5BD2E9B3B}" destId="{A550224A-B7B9-EB4D-A768-06DB806025EB}" srcOrd="1" destOrd="0" presId="urn:microsoft.com/office/officeart/2016/7/layout/BasicLinearProcessNumbered"/>
-    <dgm:cxn modelId="{ED722389-DD2C-6A41-BA55-B715B7D6365C}" type="presOf" srcId="{49F26AC4-9B33-4631-9B8C-92FA64733C20}" destId="{0D44AC74-5C85-FC4A-9D74-BCD4956FCA91}" srcOrd="0" destOrd="0" presId="urn:microsoft.com/office/officeart/2016/7/layout/BasicLinearProcessNumbered"/>
+    <dgm:cxn modelId="{08E1D010-6A2F-934F-A3AA-27F7A736BFCD}" type="presOf" srcId="{C78368A8-9612-45FF-BF42-5DF1B05E3437}" destId="{A401024C-857A-3742-92F7-DDC5FF8C9A6D}" srcOrd="0" destOrd="0" presId="urn:microsoft.com/office/officeart/2016/7/layout/BasicLinearProcessNumbered#2"/>
+    <dgm:cxn modelId="{C7A94612-31A8-4A43-867E-83B36AB575C4}" type="presOf" srcId="{49F26AC4-9B33-4631-9B8C-92FA64733C20}" destId="{47586F9C-9B54-EB4F-96C8-9783A5315693}" srcOrd="1" destOrd="0" presId="urn:microsoft.com/office/officeart/2016/7/layout/BasicLinearProcessNumbered#2"/>
+    <dgm:cxn modelId="{64BD271C-EDB3-9746-9F45-94DC0380D1C2}" type="presOf" srcId="{13C41905-E70A-2042-A000-B6D5BD2E9B3B}" destId="{27D11AC7-A0F6-A941-9745-7807865620AC}" srcOrd="0" destOrd="0" presId="urn:microsoft.com/office/officeart/2016/7/layout/BasicLinearProcessNumbered#2"/>
+    <dgm:cxn modelId="{D723361D-8E51-D041-B13D-382EF8CE38F4}" type="presOf" srcId="{B4A55DA0-D537-4F9A-A96A-206D950DE888}" destId="{8D352ACD-39F3-5746-B1C6-5768095E015B}" srcOrd="1" destOrd="0" presId="urn:microsoft.com/office/officeart/2016/7/layout/BasicLinearProcessNumbered#2"/>
+    <dgm:cxn modelId="{248AB33B-594D-A148-B525-9331469110A1}" type="presOf" srcId="{51B20956-D3F7-4822-BDF5-C5FC17434A52}" destId="{67609B28-8CEB-5E4B-B846-D3954DE0827C}" srcOrd="1" destOrd="0" presId="urn:microsoft.com/office/officeart/2016/7/layout/BasicLinearProcessNumbered#2"/>
+    <dgm:cxn modelId="{4DC53A3F-7AD0-4941-A3A9-E59C444470CD}" type="presOf" srcId="{B4A55DA0-D537-4F9A-A96A-206D950DE888}" destId="{F5531E6B-EE7E-C940-BBFC-AEA2CB55A651}" srcOrd="0" destOrd="0" presId="urn:microsoft.com/office/officeart/2016/7/layout/BasicLinearProcessNumbered#2"/>
+    <dgm:cxn modelId="{5CB7244A-8D15-6344-95ED-96F24678AC89}" type="presOf" srcId="{00EC4378-1CE3-2D4D-99C0-FBA948CA3A04}" destId="{F98F7200-0AA2-524B-8D77-69243813A5FA}" srcOrd="0" destOrd="0" presId="urn:microsoft.com/office/officeart/2016/7/layout/BasicLinearProcessNumbered#2"/>
+    <dgm:cxn modelId="{8C1D9580-0EB2-2544-83DE-6C4C15D05819}" type="presOf" srcId="{13C41905-E70A-2042-A000-B6D5BD2E9B3B}" destId="{A550224A-B7B9-EB4D-A768-06DB806025EB}" srcOrd="1" destOrd="0" presId="urn:microsoft.com/office/officeart/2016/7/layout/BasicLinearProcessNumbered#2"/>
+    <dgm:cxn modelId="{ED722389-DD2C-6A41-BA55-B715B7D6365C}" type="presOf" srcId="{49F26AC4-9B33-4631-9B8C-92FA64733C20}" destId="{0D44AC74-5C85-FC4A-9D74-BCD4956FCA91}" srcOrd="0" destOrd="0" presId="urn:microsoft.com/office/officeart/2016/7/layout/BasicLinearProcessNumbered#2"/>
     <dgm:cxn modelId="{11907789-486E-4980-8F13-C16AC5ADA0AA}" srcId="{4BEE8537-3A9F-4D93-AAF8-BF7B064184B6}" destId="{B4A55DA0-D537-4F9A-A96A-206D950DE888}" srcOrd="0" destOrd="0" parTransId="{8684FDF0-66D5-481F-AB2A-7A982DF21ABB}" sibTransId="{C78368A8-9612-45FF-BF42-5DF1B05E3437}"/>
-    <dgm:cxn modelId="{63EE6098-4EA4-644E-BD94-85BE7B929DD9}" type="presOf" srcId="{51B20956-D3F7-4822-BDF5-C5FC17434A52}" destId="{32B93B80-C473-8043-8358-73280B6FF820}" srcOrd="0" destOrd="0" presId="urn:microsoft.com/office/officeart/2016/7/layout/BasicLinearProcessNumbered"/>
-    <dgm:cxn modelId="{662A89B5-CDFD-5148-9B48-AAD59E59944D}" type="presOf" srcId="{29384AB4-D752-41CB-9858-43116D6412EC}" destId="{F53644B7-E4CD-BA4D-9930-3033535591E3}" srcOrd="0" destOrd="0" presId="urn:microsoft.com/office/officeart/2016/7/layout/BasicLinearProcessNumbered"/>
+    <dgm:cxn modelId="{63EE6098-4EA4-644E-BD94-85BE7B929DD9}" type="presOf" srcId="{51B20956-D3F7-4822-BDF5-C5FC17434A52}" destId="{32B93B80-C473-8043-8358-73280B6FF820}" srcOrd="0" destOrd="0" presId="urn:microsoft.com/office/officeart/2016/7/layout/BasicLinearProcessNumbered#2"/>
+    <dgm:cxn modelId="{662A89B5-CDFD-5148-9B48-AAD59E59944D}" type="presOf" srcId="{29384AB4-D752-41CB-9858-43116D6412EC}" destId="{F53644B7-E4CD-BA4D-9930-3033535591E3}" srcOrd="0" destOrd="0" presId="urn:microsoft.com/office/officeart/2016/7/layout/BasicLinearProcessNumbered#2"/>
     <dgm:cxn modelId="{97F98EE9-649F-44CC-86EE-EA16AD029262}" srcId="{4BEE8537-3A9F-4D93-AAF8-BF7B064184B6}" destId="{49F26AC4-9B33-4631-9B8C-92FA64733C20}" srcOrd="2" destOrd="0" parTransId="{C71DAFBC-A356-4890-8000-669EDD3CEFC4}" sibTransId="{C8027C38-2214-47BC-A081-CC8CD96E3207}"/>
-    <dgm:cxn modelId="{31517CED-5020-9542-95F3-36AB2E7411FB}" type="presOf" srcId="{C8027C38-2214-47BC-A081-CC8CD96E3207}" destId="{8AFB3681-13EE-1544-B5A1-BF90B569B3E6}" srcOrd="0" destOrd="0" presId="urn:microsoft.com/office/officeart/2016/7/layout/BasicLinearProcessNumbered"/>
+    <dgm:cxn modelId="{31517CED-5020-9542-95F3-36AB2E7411FB}" type="presOf" srcId="{C8027C38-2214-47BC-A081-CC8CD96E3207}" destId="{8AFB3681-13EE-1544-B5A1-BF90B569B3E6}" srcOrd="0" destOrd="0" presId="urn:microsoft.com/office/officeart/2016/7/layout/BasicLinearProcessNumbered#2"/>
     <dgm:cxn modelId="{9C82E4ED-2409-434B-944B-A54981FAEC4A}" srcId="{4BEE8537-3A9F-4D93-AAF8-BF7B064184B6}" destId="{13C41905-E70A-2042-A000-B6D5BD2E9B3B}" srcOrd="3" destOrd="0" parTransId="{68EA095D-96D4-A544-9645-DBB49437BE2F}" sibTransId="{00EC4378-1CE3-2D4D-99C0-FBA948CA3A04}"/>
-    <dgm:cxn modelId="{ADEF4FF2-2F66-B841-B31C-781FAA4AE60A}" type="presOf" srcId="{4BEE8537-3A9F-4D93-AAF8-BF7B064184B6}" destId="{E968CAFC-9F68-FE43-9748-2FF219222490}" srcOrd="0" destOrd="0" presId="urn:microsoft.com/office/officeart/2016/7/layout/BasicLinearProcessNumbered"/>
+    <dgm:cxn modelId="{ADEF4FF2-2F66-B841-B31C-781FAA4AE60A}" type="presOf" srcId="{4BEE8537-3A9F-4D93-AAF8-BF7B064184B6}" destId="{E968CAFC-9F68-FE43-9748-2FF219222490}" srcOrd="0" destOrd="0" presId="urn:microsoft.com/office/officeart/2016/7/layout/BasicLinearProcessNumbered#2"/>
     <dgm:cxn modelId="{45CBEAF3-104A-4C8E-BC88-0EC46705423B}" srcId="{4BEE8537-3A9F-4D93-AAF8-BF7B064184B6}" destId="{51B20956-D3F7-4822-BDF5-C5FC17434A52}" srcOrd="1" destOrd="0" parTransId="{2B8637C9-1F9B-4875-A6E6-46F90CA90ADE}" sibTransId="{29384AB4-D752-41CB-9858-43116D6412EC}"/>
-    <dgm:cxn modelId="{BF75C2E2-D74F-8142-8DC3-F762C2B63A16}" type="presParOf" srcId="{E968CAFC-9F68-FE43-9748-2FF219222490}" destId="{E2297464-C8F4-5D4F-B350-F315BE29858D}" srcOrd="0" destOrd="0" presId="urn:microsoft.com/office/officeart/2016/7/layout/BasicLinearProcessNumbered"/>
-    <dgm:cxn modelId="{93CF6CE9-CCCB-8C45-A29C-AB0C9857F184}" type="presParOf" srcId="{E2297464-C8F4-5D4F-B350-F315BE29858D}" destId="{F5531E6B-EE7E-C940-BBFC-AEA2CB55A651}" srcOrd="0" destOrd="0" presId="urn:microsoft.com/office/officeart/2016/7/layout/BasicLinearProcessNumbered"/>
-    <dgm:cxn modelId="{8A8EFED7-6C87-014C-9F6F-2B37D7A3D47B}" type="presParOf" srcId="{E2297464-C8F4-5D4F-B350-F315BE29858D}" destId="{A401024C-857A-3742-92F7-DDC5FF8C9A6D}" srcOrd="1" destOrd="0" presId="urn:microsoft.com/office/officeart/2016/7/layout/BasicLinearProcessNumbered"/>
-    <dgm:cxn modelId="{223F46E8-AB34-4149-BDBF-00065ACA19ED}" type="presParOf" srcId="{E2297464-C8F4-5D4F-B350-F315BE29858D}" destId="{9BF81B61-43D6-6A40-969F-601BB7E4DEE7}" srcOrd="2" destOrd="0" presId="urn:microsoft.com/office/officeart/2016/7/layout/BasicLinearProcessNumbered"/>
-    <dgm:cxn modelId="{C28F4C06-2490-B243-BB6A-F53A84BD2407}" type="presParOf" srcId="{E2297464-C8F4-5D4F-B350-F315BE29858D}" destId="{8D352ACD-39F3-5746-B1C6-5768095E015B}" srcOrd="3" destOrd="0" presId="urn:microsoft.com/office/officeart/2016/7/layout/BasicLinearProcessNumbered"/>
-    <dgm:cxn modelId="{6021B8B1-8F33-4645-9A6B-41F290E654CF}" type="presParOf" srcId="{E968CAFC-9F68-FE43-9748-2FF219222490}" destId="{6CFDFB64-9146-EE4F-B374-16A18BDA0A3D}" srcOrd="1" destOrd="0" presId="urn:microsoft.com/office/officeart/2016/7/layout/BasicLinearProcessNumbered"/>
-    <dgm:cxn modelId="{62468F63-8437-5840-99C6-F92B690570BB}" type="presParOf" srcId="{E968CAFC-9F68-FE43-9748-2FF219222490}" destId="{144DAB64-3E89-9047-BC93-55C7D8BB7D39}" srcOrd="2" destOrd="0" presId="urn:microsoft.com/office/officeart/2016/7/layout/BasicLinearProcessNumbered"/>
-    <dgm:cxn modelId="{A9D2865B-7369-A746-B193-4C49A5FCA660}" type="presParOf" srcId="{144DAB64-3E89-9047-BC93-55C7D8BB7D39}" destId="{32B93B80-C473-8043-8358-73280B6FF820}" srcOrd="0" destOrd="0" presId="urn:microsoft.com/office/officeart/2016/7/layout/BasicLinearProcessNumbered"/>
-    <dgm:cxn modelId="{8EA5759A-9757-FB4F-BD1C-FFB19E23D590}" type="presParOf" srcId="{144DAB64-3E89-9047-BC93-55C7D8BB7D39}" destId="{F53644B7-E4CD-BA4D-9930-3033535591E3}" srcOrd="1" destOrd="0" presId="urn:microsoft.com/office/officeart/2016/7/layout/BasicLinearProcessNumbered"/>
-    <dgm:cxn modelId="{2B6B2126-CCEB-C94A-929F-10A9732B2086}" type="presParOf" srcId="{144DAB64-3E89-9047-BC93-55C7D8BB7D39}" destId="{DA12CE4D-73DF-6749-8F2C-55B36F986FB5}" srcOrd="2" destOrd="0" presId="urn:microsoft.com/office/officeart/2016/7/layout/BasicLinearProcessNumbered"/>
-    <dgm:cxn modelId="{22CCF0C0-BDE5-FD4C-BAA6-554FAFF8DF68}" type="presParOf" srcId="{144DAB64-3E89-9047-BC93-55C7D8BB7D39}" destId="{67609B28-8CEB-5E4B-B846-D3954DE0827C}" srcOrd="3" destOrd="0" presId="urn:microsoft.com/office/officeart/2016/7/layout/BasicLinearProcessNumbered"/>
-    <dgm:cxn modelId="{E0D98C00-375C-ED4F-8041-D001CC88E725}" type="presParOf" srcId="{E968CAFC-9F68-FE43-9748-2FF219222490}" destId="{2B7B08F4-5404-7B44-A810-FC3F5D6DD758}" srcOrd="3" destOrd="0" presId="urn:microsoft.com/office/officeart/2016/7/layout/BasicLinearProcessNumbered"/>
-    <dgm:cxn modelId="{ECB20B46-8DC8-BA4D-A911-21F82D00F3A8}" type="presParOf" srcId="{E968CAFC-9F68-FE43-9748-2FF219222490}" destId="{7A913FF0-D7B7-A949-BD39-261C3AB01269}" srcOrd="4" destOrd="0" presId="urn:microsoft.com/office/officeart/2016/7/layout/BasicLinearProcessNumbered"/>
-    <dgm:cxn modelId="{42D55C35-B69B-F340-AE07-F22790E443E9}" type="presParOf" srcId="{7A913FF0-D7B7-A949-BD39-261C3AB01269}" destId="{0D44AC74-5C85-FC4A-9D74-BCD4956FCA91}" srcOrd="0" destOrd="0" presId="urn:microsoft.com/office/officeart/2016/7/layout/BasicLinearProcessNumbered"/>
-    <dgm:cxn modelId="{9FBEEF6E-86DF-284D-B50B-8DB09B086B70}" type="presParOf" srcId="{7A913FF0-D7B7-A949-BD39-261C3AB01269}" destId="{8AFB3681-13EE-1544-B5A1-BF90B569B3E6}" srcOrd="1" destOrd="0" presId="urn:microsoft.com/office/officeart/2016/7/layout/BasicLinearProcessNumbered"/>
-    <dgm:cxn modelId="{1F2A94F4-E5DC-2847-8079-F05941491160}" type="presParOf" srcId="{7A913FF0-D7B7-A949-BD39-261C3AB01269}" destId="{7449331E-1B11-3141-ADBA-73DEF6C17A26}" srcOrd="2" destOrd="0" presId="urn:microsoft.com/office/officeart/2016/7/layout/BasicLinearProcessNumbered"/>
-    <dgm:cxn modelId="{20DB4CE8-B8AA-1D4B-8FBE-9CEA9C9FF1F4}" type="presParOf" srcId="{7A913FF0-D7B7-A949-BD39-261C3AB01269}" destId="{47586F9C-9B54-EB4F-96C8-9783A5315693}" srcOrd="3" destOrd="0" presId="urn:microsoft.com/office/officeart/2016/7/layout/BasicLinearProcessNumbered"/>
-    <dgm:cxn modelId="{91191685-0E00-3A4B-A8C8-E3361A812820}" type="presParOf" srcId="{E968CAFC-9F68-FE43-9748-2FF219222490}" destId="{2A7802F4-BEB6-EA47-8EED-D3DCE7800C9A}" srcOrd="5" destOrd="0" presId="urn:microsoft.com/office/officeart/2016/7/layout/BasicLinearProcessNumbered"/>
-    <dgm:cxn modelId="{8927EF30-89A0-6140-B9C6-4CDBC30FA883}" type="presParOf" srcId="{E968CAFC-9F68-FE43-9748-2FF219222490}" destId="{D58E89CE-0696-9448-B843-D8CE17FB8E1F}" srcOrd="6" destOrd="0" presId="urn:microsoft.com/office/officeart/2016/7/layout/BasicLinearProcessNumbered"/>
-    <dgm:cxn modelId="{A0AA3ADF-FBB3-4C47-9A4F-9002E0E8DD28}" type="presParOf" srcId="{D58E89CE-0696-9448-B843-D8CE17FB8E1F}" destId="{27D11AC7-A0F6-A941-9745-7807865620AC}" srcOrd="0" destOrd="0" presId="urn:microsoft.com/office/officeart/2016/7/layout/BasicLinearProcessNumbered"/>
-    <dgm:cxn modelId="{78287DEB-B150-6247-B9D7-CFFD284DE775}" type="presParOf" srcId="{D58E89CE-0696-9448-B843-D8CE17FB8E1F}" destId="{F98F7200-0AA2-524B-8D77-69243813A5FA}" srcOrd="1" destOrd="0" presId="urn:microsoft.com/office/officeart/2016/7/layout/BasicLinearProcessNumbered"/>
-    <dgm:cxn modelId="{1C721DC8-F0C9-B242-AF5F-E76910ED5DC0}" type="presParOf" srcId="{D58E89CE-0696-9448-B843-D8CE17FB8E1F}" destId="{C581505F-92FA-DB4D-A701-913FFA1DBE0C}" srcOrd="2" destOrd="0" presId="urn:microsoft.com/office/officeart/2016/7/layout/BasicLinearProcessNumbered"/>
-    <dgm:cxn modelId="{7DA6A597-5E0B-B349-885B-FA7548453F5C}" type="presParOf" srcId="{D58E89CE-0696-9448-B843-D8CE17FB8E1F}" destId="{A550224A-B7B9-EB4D-A768-06DB806025EB}" srcOrd="3" destOrd="0" presId="urn:microsoft.com/office/officeart/2016/7/layout/BasicLinearProcessNumbered"/>
+    <dgm:cxn modelId="{BF75C2E2-D74F-8142-8DC3-F762C2B63A16}" type="presParOf" srcId="{E968CAFC-9F68-FE43-9748-2FF219222490}" destId="{E2297464-C8F4-5D4F-B350-F315BE29858D}" srcOrd="0" destOrd="0" presId="urn:microsoft.com/office/officeart/2016/7/layout/BasicLinearProcessNumbered#2"/>
+    <dgm:cxn modelId="{93CF6CE9-CCCB-8C45-A29C-AB0C9857F184}" type="presParOf" srcId="{E2297464-C8F4-5D4F-B350-F315BE29858D}" destId="{F5531E6B-EE7E-C940-BBFC-AEA2CB55A651}" srcOrd="0" destOrd="0" presId="urn:microsoft.com/office/officeart/2016/7/layout/BasicLinearProcessNumbered#2"/>
+    <dgm:cxn modelId="{8A8EFED7-6C87-014C-9F6F-2B37D7A3D47B}" type="presParOf" srcId="{E2297464-C8F4-5D4F-B350-F315BE29858D}" destId="{A401024C-857A-3742-92F7-DDC5FF8C9A6D}" srcOrd="1" destOrd="0" presId="urn:microsoft.com/office/officeart/2016/7/layout/BasicLinearProcessNumbered#2"/>
+    <dgm:cxn modelId="{223F46E8-AB34-4149-BDBF-00065ACA19ED}" type="presParOf" srcId="{E2297464-C8F4-5D4F-B350-F315BE29858D}" destId="{9BF81B61-43D6-6A40-969F-601BB7E4DEE7}" srcOrd="2" destOrd="0" presId="urn:microsoft.com/office/officeart/2016/7/layout/BasicLinearProcessNumbered#2"/>
+    <dgm:cxn modelId="{C28F4C06-2490-B243-BB6A-F53A84BD2407}" type="presParOf" srcId="{E2297464-C8F4-5D4F-B350-F315BE29858D}" destId="{8D352ACD-39F3-5746-B1C6-5768095E015B}" srcOrd="3" destOrd="0" presId="urn:microsoft.com/office/officeart/2016/7/layout/BasicLinearProcessNumbered#2"/>
+    <dgm:cxn modelId="{6021B8B1-8F33-4645-9A6B-41F290E654CF}" type="presParOf" srcId="{E968CAFC-9F68-FE43-9748-2FF219222490}" destId="{6CFDFB64-9146-EE4F-B374-16A18BDA0A3D}" srcOrd="1" destOrd="0" presId="urn:microsoft.com/office/officeart/2016/7/layout/BasicLinearProcessNumbered#2"/>
+    <dgm:cxn modelId="{62468F63-8437-5840-99C6-F92B690570BB}" type="presParOf" srcId="{E968CAFC-9F68-FE43-9748-2FF219222490}" destId="{144DAB64-3E89-9047-BC93-55C7D8BB7D39}" srcOrd="2" destOrd="0" presId="urn:microsoft.com/office/officeart/2016/7/layout/BasicLinearProcessNumbered#2"/>
+    <dgm:cxn modelId="{A9D2865B-7369-A746-B193-4C49A5FCA660}" type="presParOf" srcId="{144DAB64-3E89-9047-BC93-55C7D8BB7D39}" destId="{32B93B80-C473-8043-8358-73280B6FF820}" srcOrd="0" destOrd="0" presId="urn:microsoft.com/office/officeart/2016/7/layout/BasicLinearProcessNumbered#2"/>
+    <dgm:cxn modelId="{8EA5759A-9757-FB4F-BD1C-FFB19E23D590}" type="presParOf" srcId="{144DAB64-3E89-9047-BC93-55C7D8BB7D39}" destId="{F53644B7-E4CD-BA4D-9930-3033535591E3}" srcOrd="1" destOrd="0" presId="urn:microsoft.com/office/officeart/2016/7/layout/BasicLinearProcessNumbered#2"/>
+    <dgm:cxn modelId="{2B6B2126-CCEB-C94A-929F-10A9732B2086}" type="presParOf" srcId="{144DAB64-3E89-9047-BC93-55C7D8BB7D39}" destId="{DA12CE4D-73DF-6749-8F2C-55B36F986FB5}" srcOrd="2" destOrd="0" presId="urn:microsoft.com/office/officeart/2016/7/layout/BasicLinearProcessNumbered#2"/>
+    <dgm:cxn modelId="{22CCF0C0-BDE5-FD4C-BAA6-554FAFF8DF68}" type="presParOf" srcId="{144DAB64-3E89-9047-BC93-55C7D8BB7D39}" destId="{67609B28-8CEB-5E4B-B846-D3954DE0827C}" srcOrd="3" destOrd="0" presId="urn:microsoft.com/office/officeart/2016/7/layout/BasicLinearProcessNumbered#2"/>
+    <dgm:cxn modelId="{E0D98C00-375C-ED4F-8041-D001CC88E725}" type="presParOf" srcId="{E968CAFC-9F68-FE43-9748-2FF219222490}" destId="{2B7B08F4-5404-7B44-A810-FC3F5D6DD758}" srcOrd="3" destOrd="0" presId="urn:microsoft.com/office/officeart/2016/7/layout/BasicLinearProcessNumbered#2"/>
+    <dgm:cxn modelId="{ECB20B46-8DC8-BA4D-A911-21F82D00F3A8}" type="presParOf" srcId="{E968CAFC-9F68-FE43-9748-2FF219222490}" destId="{7A913FF0-D7B7-A949-BD39-261C3AB01269}" srcOrd="4" destOrd="0" presId="urn:microsoft.com/office/officeart/2016/7/layout/BasicLinearProcessNumbered#2"/>
+    <dgm:cxn modelId="{42D55C35-B69B-F340-AE07-F22790E443E9}" type="presParOf" srcId="{7A913FF0-D7B7-A949-BD39-261C3AB01269}" destId="{0D44AC74-5C85-FC4A-9D74-BCD4956FCA91}" srcOrd="0" destOrd="0" presId="urn:microsoft.com/office/officeart/2016/7/layout/BasicLinearProcessNumbered#2"/>
+    <dgm:cxn modelId="{9FBEEF6E-86DF-284D-B50B-8DB09B086B70}" type="presParOf" srcId="{7A913FF0-D7B7-A949-BD39-261C3AB01269}" destId="{8AFB3681-13EE-1544-B5A1-BF90B569B3E6}" srcOrd="1" destOrd="0" presId="urn:microsoft.com/office/officeart/2016/7/layout/BasicLinearProcessNumbered#2"/>
+    <dgm:cxn modelId="{1F2A94F4-E5DC-2847-8079-F05941491160}" type="presParOf" srcId="{7A913FF0-D7B7-A949-BD39-261C3AB01269}" destId="{7449331E-1B11-3141-ADBA-73DEF6C17A26}" srcOrd="2" destOrd="0" presId="urn:microsoft.com/office/officeart/2016/7/layout/BasicLinearProcessNumbered#2"/>
+    <dgm:cxn modelId="{20DB4CE8-B8AA-1D4B-8FBE-9CEA9C9FF1F4}" type="presParOf" srcId="{7A913FF0-D7B7-A949-BD39-261C3AB01269}" destId="{47586F9C-9B54-EB4F-96C8-9783A5315693}" srcOrd="3" destOrd="0" presId="urn:microsoft.com/office/officeart/2016/7/layout/BasicLinearProcessNumbered#2"/>
+    <dgm:cxn modelId="{91191685-0E00-3A4B-A8C8-E3361A812820}" type="presParOf" srcId="{E968CAFC-9F68-FE43-9748-2FF219222490}" destId="{2A7802F4-BEB6-EA47-8EED-D3DCE7800C9A}" srcOrd="5" destOrd="0" presId="urn:microsoft.com/office/officeart/2016/7/layout/BasicLinearProcessNumbered#2"/>
+    <dgm:cxn modelId="{8927EF30-89A0-6140-B9C6-4CDBC30FA883}" type="presParOf" srcId="{E968CAFC-9F68-FE43-9748-2FF219222490}" destId="{D58E89CE-0696-9448-B843-D8CE17FB8E1F}" srcOrd="6" destOrd="0" presId="urn:microsoft.com/office/officeart/2016/7/layout/BasicLinearProcessNumbered#2"/>
+    <dgm:cxn modelId="{A0AA3ADF-FBB3-4C47-9A4F-9002E0E8DD28}" type="presParOf" srcId="{D58E89CE-0696-9448-B843-D8CE17FB8E1F}" destId="{27D11AC7-A0F6-A941-9745-7807865620AC}" srcOrd="0" destOrd="0" presId="urn:microsoft.com/office/officeart/2016/7/layout/BasicLinearProcessNumbered#2"/>
+    <dgm:cxn modelId="{78287DEB-B150-6247-B9D7-CFFD284DE775}" type="presParOf" srcId="{D58E89CE-0696-9448-B843-D8CE17FB8E1F}" destId="{F98F7200-0AA2-524B-8D77-69243813A5FA}" srcOrd="1" destOrd="0" presId="urn:microsoft.com/office/officeart/2016/7/layout/BasicLinearProcessNumbered#2"/>
+    <dgm:cxn modelId="{1C721DC8-F0C9-B242-AF5F-E76910ED5DC0}" type="presParOf" srcId="{D58E89CE-0696-9448-B843-D8CE17FB8E1F}" destId="{C581505F-92FA-DB4D-A701-913FFA1DBE0C}" srcOrd="2" destOrd="0" presId="urn:microsoft.com/office/officeart/2016/7/layout/BasicLinearProcessNumbered#2"/>
+    <dgm:cxn modelId="{7DA6A597-5E0B-B349-885B-FA7548453F5C}" type="presParOf" srcId="{D58E89CE-0696-9448-B843-D8CE17FB8E1F}" destId="{A550224A-B7B9-EB4D-A768-06DB806025EB}" srcOrd="3" destOrd="0" presId="urn:microsoft.com/office/officeart/2016/7/layout/BasicLinearProcessNumbered#2"/>
   </dgm:cxnLst>
   <dgm:bg/>
   <dgm:whole/>
@@ -4760,7 +4766,7 @@
 </file>
 
 <file path=ppt/diagrams/layout1.xml><?xml version="1.0" encoding="utf-8"?>
-<dgm:layoutDef xmlns:dgm="http://schemas.openxmlformats.org/drawingml/2006/diagram" xmlns:a="http://schemas.openxmlformats.org/drawingml/2006/main" uniqueId="urn:microsoft.com/office/officeart/2016/7/layout/BasicLinearProcessNumbered">
+<dgm:layoutDef xmlns:dgm="http://schemas.openxmlformats.org/drawingml/2006/diagram" xmlns:a="http://schemas.openxmlformats.org/drawingml/2006/main" uniqueId="urn:microsoft.com/office/officeart/2016/7/layout/BasicLinearProcessNumbered#2">
   <dgm:title val="Basic Linear Process Numbered"/>
   <dgm:desc val="Used to show a progression; a timeline; sequential steps in a task, process, or workflow; or to emphasize movement or direction. Automatic numbers have been introduced to show the steps of the process which appears in a circle. Level 1 and Level 2 text appear in a rectangle."/>
   <dgm:catLst>
@@ -7463,7 +7469,7 @@
           <a:p>
             <a:fld id="{D312B525-617A-C241-8A56-D36B95741A54}" type="datetimeFigureOut">
               <a:rPr lang="en-US" smtClean="0"/>
-              <a:t>10/20/26</a:t>
+              <a:t>10/21/26</a:t>
             </a:fld>
             <a:endParaRPr lang="en-US"/>
           </a:p>
@@ -7814,426 +7820,7 @@
 </p:notes>
 </file>
 
-<file path=ppt/notesSlides/notesSlide2.xml><?xml version="1.0" encoding="utf-8"?>
-<p:notes xmlns:a="http://schemas.openxmlformats.org/drawingml/2006/main" xmlns:r="http://schemas.openxmlformats.org/officeDocument/2006/relationships" xmlns:p="http://schemas.openxmlformats.org/presentationml/2006/main">
-  <p:cSld>
-    <p:spTree>
-      <p:nvGrpSpPr>
-        <p:cNvPr id="1" name=""/>
-        <p:cNvGrpSpPr/>
-        <p:nvPr/>
-      </p:nvGrpSpPr>
-      <p:grpSpPr>
-        <a:xfrm>
-          <a:off x="0" y="0"/>
-          <a:ext cx="0" cy="0"/>
-          <a:chOff x="0" y="0"/>
-          <a:chExt cx="0" cy="0"/>
-        </a:xfrm>
-      </p:grpSpPr>
-      <p:sp>
-        <p:nvSpPr>
-          <p:cNvPr id="2" name="Slide Image Placeholder 1"/>
-          <p:cNvSpPr>
-            <a:spLocks noGrp="1" noRot="1" noChangeAspect="1"/>
-          </p:cNvSpPr>
-          <p:nvPr>
-            <p:ph type="sldImg"/>
-          </p:nvPr>
-        </p:nvSpPr>
-        <p:spPr/>
-      </p:sp>
-      <p:sp>
-        <p:nvSpPr>
-          <p:cNvPr id="3" name="Notes Placeholder 2"/>
-          <p:cNvSpPr>
-            <a:spLocks noGrp="1"/>
-          </p:cNvSpPr>
-          <p:nvPr>
-            <p:ph type="body" idx="1"/>
-          </p:nvPr>
-        </p:nvSpPr>
-        <p:spPr/>
-        <p:txBody>
-          <a:bodyPr/>
-          <a:lstStyle/>
-          <a:p>
-            <a:r>
-              <a:rPr lang="en-US" dirty="0"/>
-              <a:t>A standard normal distribution has a  mean is 0 and the standard deviation is 1. 68% of all values should fall within 1 SD of the mean, 95% of all values should fall within 2 SD of the mean. Values under the tails of the distribution are highly unlikely! We can calculate p-values by plotting our observed value on simulated normally distributed data ( if H0 is true) to see what the probability of getting our observed data is if H0 is true. </a:t>
-            </a:r>
-          </a:p>
-          <a:p>
-            <a:r>
-              <a:rPr lang="en-US" dirty="0">
-                <a:solidFill>
-                  <a:srgbClr val="FFFFFF"/>
-                </a:solidFill>
-              </a:rPr>
-              <a:t>. It can be used to calculate the probability of a certain value’s distance from the mean via the z-score.</a:t>
-            </a:r>
-            <a:endParaRPr lang="en-US" dirty="0"/>
-          </a:p>
-          <a:p>
-            <a:endParaRPr lang="en-US" dirty="0"/>
-          </a:p>
-        </p:txBody>
-      </p:sp>
-      <p:sp>
-        <p:nvSpPr>
-          <p:cNvPr id="4" name="Slide Number Placeholder 3"/>
-          <p:cNvSpPr>
-            <a:spLocks noGrp="1"/>
-          </p:cNvSpPr>
-          <p:nvPr>
-            <p:ph type="sldNum" sz="quarter" idx="5"/>
-          </p:nvPr>
-        </p:nvSpPr>
-        <p:spPr/>
-        <p:txBody>
-          <a:bodyPr/>
-          <a:lstStyle/>
-          <a:p>
-            <a:fld id="{7DB159D7-3F9A-5C49-B0CF-E7444B3B457F}" type="slidenum">
-              <a:rPr lang="en-US" smtClean="0"/>
-              <a:t>3</a:t>
-            </a:fld>
-            <a:endParaRPr lang="en-US"/>
-          </a:p>
-        </p:txBody>
-      </p:sp>
-    </p:spTree>
-    <p:extLst>
-      <p:ext uri="{BB962C8B-B14F-4D97-AF65-F5344CB8AC3E}">
-        <p14:creationId xmlns:p14="http://schemas.microsoft.com/office/powerpoint/2010/main" val="1412741741"/>
-      </p:ext>
-    </p:extLst>
-  </p:cSld>
-  <p:clrMapOvr>
-    <a:masterClrMapping/>
-  </p:clrMapOvr>
-</p:notes>
-</file>
-
-<file path=ppt/notesSlides/notesSlide3.xml><?xml version="1.0" encoding="utf-8"?>
-<p:notes xmlns:a="http://schemas.openxmlformats.org/drawingml/2006/main" xmlns:r="http://schemas.openxmlformats.org/officeDocument/2006/relationships" xmlns:p="http://schemas.openxmlformats.org/presentationml/2006/main">
-  <p:cSld>
-    <p:spTree>
-      <p:nvGrpSpPr>
-        <p:cNvPr id="1" name=""/>
-        <p:cNvGrpSpPr/>
-        <p:nvPr/>
-      </p:nvGrpSpPr>
-      <p:grpSpPr>
-        <a:xfrm>
-          <a:off x="0" y="0"/>
-          <a:ext cx="0" cy="0"/>
-          <a:chOff x="0" y="0"/>
-          <a:chExt cx="0" cy="0"/>
-        </a:xfrm>
-      </p:grpSpPr>
-      <p:sp>
-        <p:nvSpPr>
-          <p:cNvPr id="2" name="Slide Image Placeholder 1"/>
-          <p:cNvSpPr>
-            <a:spLocks noGrp="1" noRot="1" noChangeAspect="1"/>
-          </p:cNvSpPr>
-          <p:nvPr>
-            <p:ph type="sldImg"/>
-          </p:nvPr>
-        </p:nvSpPr>
-        <p:spPr/>
-      </p:sp>
-      <p:sp>
-        <p:nvSpPr>
-          <p:cNvPr id="3" name="Notes Placeholder 2"/>
-          <p:cNvSpPr>
-            <a:spLocks noGrp="1"/>
-          </p:cNvSpPr>
-          <p:nvPr>
-            <p:ph type="body" idx="1"/>
-          </p:nvPr>
-        </p:nvSpPr>
-        <p:spPr/>
-        <p:txBody>
-          <a:bodyPr/>
-          <a:lstStyle/>
-          <a:p>
-            <a:r>
-              <a:rPr lang="en-US" dirty="0" err="1"/>
-              <a:t>Postiive</a:t>
-            </a:r>
-            <a:r>
-              <a:rPr lang="en-US" dirty="0"/>
-              <a:t> or </a:t>
-            </a:r>
-            <a:r>
-              <a:rPr lang="en-US" dirty="0" err="1"/>
-              <a:t>righ</a:t>
-            </a:r>
-            <a:r>
-              <a:rPr lang="en-US" dirty="0"/>
-              <a:t> skewed data has a long tail to the right and negative or left skewed data has a long tail to the left. Note that in our skewed data we much different values that are less probably when compared to the </a:t>
-            </a:r>
-            <a:r>
-              <a:rPr lang="en-US" dirty="0" err="1"/>
-              <a:t>nomral</a:t>
-            </a:r>
-            <a:r>
-              <a:rPr lang="en-US" dirty="0"/>
-              <a:t> distribution. </a:t>
-            </a:r>
-            <a:r>
-              <a:rPr lang="en-US" dirty="0" err="1"/>
-              <a:t>Kurtosiss</a:t>
-            </a:r>
-            <a:r>
-              <a:rPr lang="en-US" dirty="0"/>
-              <a:t> is the measure of how the SD differs really, where slender distribution with long flat tails is called leptokurtic and a distribution that has short tails and a broad distribution is </a:t>
-            </a:r>
-            <a:r>
-              <a:rPr lang="en-US" dirty="0" err="1"/>
-              <a:t>lcalled</a:t>
-            </a:r>
-            <a:r>
-              <a:rPr lang="en-US" dirty="0"/>
-              <a:t> platykurtic. </a:t>
-            </a:r>
-          </a:p>
-        </p:txBody>
-      </p:sp>
-      <p:sp>
-        <p:nvSpPr>
-          <p:cNvPr id="4" name="Slide Number Placeholder 3"/>
-          <p:cNvSpPr>
-            <a:spLocks noGrp="1"/>
-          </p:cNvSpPr>
-          <p:nvPr>
-            <p:ph type="sldNum" sz="quarter" idx="5"/>
-          </p:nvPr>
-        </p:nvSpPr>
-        <p:spPr/>
-        <p:txBody>
-          <a:bodyPr/>
-          <a:lstStyle/>
-          <a:p>
-            <a:fld id="{7DB159D7-3F9A-5C49-B0CF-E7444B3B457F}" type="slidenum">
-              <a:rPr lang="en-US" smtClean="0"/>
-              <a:t>4</a:t>
-            </a:fld>
-            <a:endParaRPr lang="en-US"/>
-          </a:p>
-        </p:txBody>
-      </p:sp>
-    </p:spTree>
-    <p:extLst>
-      <p:ext uri="{BB962C8B-B14F-4D97-AF65-F5344CB8AC3E}">
-        <p14:creationId xmlns:p14="http://schemas.microsoft.com/office/powerpoint/2010/main" val="1616898590"/>
-      </p:ext>
-    </p:extLst>
-  </p:cSld>
-  <p:clrMapOvr>
-    <a:masterClrMapping/>
-  </p:clrMapOvr>
-</p:notes>
-</file>
-
-<file path=ppt/notesSlides/notesSlide4.xml><?xml version="1.0" encoding="utf-8"?>
-<p:notes xmlns:a="http://schemas.openxmlformats.org/drawingml/2006/main" xmlns:r="http://schemas.openxmlformats.org/officeDocument/2006/relationships" xmlns:p="http://schemas.openxmlformats.org/presentationml/2006/main">
-  <p:cSld>
-    <p:spTree>
-      <p:nvGrpSpPr>
-        <p:cNvPr id="1" name=""/>
-        <p:cNvGrpSpPr/>
-        <p:nvPr/>
-      </p:nvGrpSpPr>
-      <p:grpSpPr>
-        <a:xfrm>
-          <a:off x="0" y="0"/>
-          <a:ext cx="0" cy="0"/>
-          <a:chOff x="0" y="0"/>
-          <a:chExt cx="0" cy="0"/>
-        </a:xfrm>
-      </p:grpSpPr>
-      <p:sp>
-        <p:nvSpPr>
-          <p:cNvPr id="2" name="Slide Image Placeholder 1"/>
-          <p:cNvSpPr>
-            <a:spLocks noGrp="1" noRot="1" noChangeAspect="1"/>
-          </p:cNvSpPr>
-          <p:nvPr>
-            <p:ph type="sldImg"/>
-          </p:nvPr>
-        </p:nvSpPr>
-        <p:spPr/>
-      </p:sp>
-      <p:sp>
-        <p:nvSpPr>
-          <p:cNvPr id="3" name="Notes Placeholder 2"/>
-          <p:cNvSpPr>
-            <a:spLocks noGrp="1"/>
-          </p:cNvSpPr>
-          <p:nvPr>
-            <p:ph type="body" idx="1"/>
-          </p:nvPr>
-        </p:nvSpPr>
-        <p:spPr/>
-        <p:txBody>
-          <a:bodyPr/>
-          <a:lstStyle/>
-          <a:p>
-            <a:r>
-              <a:rPr lang="en-US" dirty="0"/>
-              <a:t>We use ln() natural log in r instead of log10 because it is standard practice, easier to back transform and easier to scale. </a:t>
-            </a:r>
-          </a:p>
-        </p:txBody>
-      </p:sp>
-      <p:sp>
-        <p:nvSpPr>
-          <p:cNvPr id="4" name="Slide Number Placeholder 3"/>
-          <p:cNvSpPr>
-            <a:spLocks noGrp="1"/>
-          </p:cNvSpPr>
-          <p:nvPr>
-            <p:ph type="sldNum" sz="quarter" idx="5"/>
-          </p:nvPr>
-        </p:nvSpPr>
-        <p:spPr/>
-        <p:txBody>
-          <a:bodyPr/>
-          <a:lstStyle/>
-          <a:p>
-            <a:fld id="{7DB159D7-3F9A-5C49-B0CF-E7444B3B457F}" type="slidenum">
-              <a:rPr lang="en-US" smtClean="0"/>
-              <a:t>6</a:t>
-            </a:fld>
-            <a:endParaRPr lang="en-US"/>
-          </a:p>
-        </p:txBody>
-      </p:sp>
-    </p:spTree>
-    <p:extLst>
-      <p:ext uri="{BB962C8B-B14F-4D97-AF65-F5344CB8AC3E}">
-        <p14:creationId xmlns:p14="http://schemas.microsoft.com/office/powerpoint/2010/main" val="43732012"/>
-      </p:ext>
-    </p:extLst>
-  </p:cSld>
-  <p:clrMapOvr>
-    <a:masterClrMapping/>
-  </p:clrMapOvr>
-</p:notes>
-</file>
-
-<file path=ppt/notesSlides/notesSlide5.xml><?xml version="1.0" encoding="utf-8"?>
-<p:notes xmlns:a="http://schemas.openxmlformats.org/drawingml/2006/main" xmlns:r="http://schemas.openxmlformats.org/officeDocument/2006/relationships" xmlns:p="http://schemas.openxmlformats.org/presentationml/2006/main">
-  <p:cSld>
-    <p:spTree>
-      <p:nvGrpSpPr>
-        <p:cNvPr id="1" name=""/>
-        <p:cNvGrpSpPr/>
-        <p:nvPr/>
-      </p:nvGrpSpPr>
-      <p:grpSpPr>
-        <a:xfrm>
-          <a:off x="0" y="0"/>
-          <a:ext cx="0" cy="0"/>
-          <a:chOff x="0" y="0"/>
-          <a:chExt cx="0" cy="0"/>
-        </a:xfrm>
-      </p:grpSpPr>
-      <p:sp>
-        <p:nvSpPr>
-          <p:cNvPr id="2" name="Slide Image Placeholder 1"/>
-          <p:cNvSpPr>
-            <a:spLocks noGrp="1" noRot="1" noChangeAspect="1"/>
-          </p:cNvSpPr>
-          <p:nvPr>
-            <p:ph type="sldImg"/>
-          </p:nvPr>
-        </p:nvSpPr>
-        <p:spPr/>
-      </p:sp>
-      <p:sp>
-        <p:nvSpPr>
-          <p:cNvPr id="3" name="Notes Placeholder 2"/>
-          <p:cNvSpPr>
-            <a:spLocks noGrp="1"/>
-          </p:cNvSpPr>
-          <p:nvPr>
-            <p:ph type="body" idx="1"/>
-          </p:nvPr>
-        </p:nvSpPr>
-        <p:spPr/>
-        <p:txBody>
-          <a:bodyPr/>
-          <a:lstStyle/>
-          <a:p>
-            <a:r>
-              <a:rPr lang="en-US" dirty="0"/>
-              <a:t>Q-Q plots show you how much your data deviates from the normal distribution. If your data aligns perfectly with the normal distribution, the points will fall along the line. </a:t>
-            </a:r>
-            <a:r>
-              <a:rPr lang="en-US" sz="1200" b="0" i="0" kern="1200" dirty="0">
-                <a:solidFill>
-                  <a:schemeClr val="tx1"/>
-                </a:solidFill>
-                <a:effectLst/>
-                <a:latin typeface="+mn-lt"/>
-                <a:ea typeface="+mn-ea"/>
-                <a:cs typeface="+mn-cs"/>
-              </a:rPr>
-              <a:t> A Q-Q (quantile-quantile) plot compares your data’s distribution against a theoretical normal distribution. If your data is normal, the points fall along a straight diagonal line. Right-skewed data produces a curve that bows away from the line. Heavy-tailed data (more extreme values than expected) follows the line in the middle but curves off at both ends.</a:t>
-            </a:r>
-          </a:p>
-          <a:p>
-            <a:br>
-              <a:rPr lang="en-US" dirty="0"/>
-            </a:br>
-            <a:r>
-              <a:rPr lang="en-US" dirty="0"/>
-              <a:t>- can also use a Shapiro-wilk test to test for normality. </a:t>
-            </a:r>
-          </a:p>
-        </p:txBody>
-      </p:sp>
-      <p:sp>
-        <p:nvSpPr>
-          <p:cNvPr id="4" name="Slide Number Placeholder 3"/>
-          <p:cNvSpPr>
-            <a:spLocks noGrp="1"/>
-          </p:cNvSpPr>
-          <p:nvPr>
-            <p:ph type="sldNum" sz="quarter" idx="5"/>
-          </p:nvPr>
-        </p:nvSpPr>
-        <p:spPr/>
-        <p:txBody>
-          <a:bodyPr/>
-          <a:lstStyle/>
-          <a:p>
-            <a:fld id="{7DB159D7-3F9A-5C49-B0CF-E7444B3B457F}" type="slidenum">
-              <a:rPr lang="en-US" smtClean="0"/>
-              <a:t>7</a:t>
-            </a:fld>
-            <a:endParaRPr lang="en-US"/>
-          </a:p>
-        </p:txBody>
-      </p:sp>
-    </p:spTree>
-    <p:extLst>
-      <p:ext uri="{BB962C8B-B14F-4D97-AF65-F5344CB8AC3E}">
-        <p14:creationId xmlns:p14="http://schemas.microsoft.com/office/powerpoint/2010/main" val="720027104"/>
-      </p:ext>
-    </p:extLst>
-  </p:cSld>
-  <p:clrMapOvr>
-    <a:masterClrMapping/>
-  </p:clrMapOvr>
-</p:notes>
-</file>
-
-<file path=ppt/notesSlides/notesSlide6.xml><?xml version="1.0" encoding="utf-8"?>
+<file path=ppt/notesSlides/notesSlide10.xml><?xml version="1.0" encoding="utf-8"?>
 <p:notes xmlns:a="http://schemas.openxmlformats.org/drawingml/2006/main" xmlns:r="http://schemas.openxmlformats.org/officeDocument/2006/relationships" xmlns:p="http://schemas.openxmlformats.org/presentationml/2006/main">
   <p:cSld>
     <p:spTree>
@@ -8322,7 +7909,7 @@
           <a:p>
             <a:fld id="{7DB159D7-3F9A-5C49-B0CF-E7444B3B457F}" type="slidenum">
               <a:rPr lang="en-US" smtClean="0"/>
-              <a:t>13</a:t>
+              <a:t>14</a:t>
             </a:fld>
             <a:endParaRPr lang="en-US"/>
           </a:p>
@@ -8332,6 +7919,948 @@
     <p:extLst>
       <p:ext uri="{BB962C8B-B14F-4D97-AF65-F5344CB8AC3E}">
         <p14:creationId xmlns:p14="http://schemas.microsoft.com/office/powerpoint/2010/main" val="2904309545"/>
+      </p:ext>
+    </p:extLst>
+  </p:cSld>
+  <p:clrMapOvr>
+    <a:masterClrMapping/>
+  </p:clrMapOvr>
+</p:notes>
+</file>
+
+<file path=ppt/notesSlides/notesSlide2.xml><?xml version="1.0" encoding="utf-8"?>
+<p:notes xmlns:a="http://schemas.openxmlformats.org/drawingml/2006/main" xmlns:r="http://schemas.openxmlformats.org/officeDocument/2006/relationships" xmlns:p="http://schemas.openxmlformats.org/presentationml/2006/main">
+  <p:cSld>
+    <p:spTree>
+      <p:nvGrpSpPr>
+        <p:cNvPr id="1" name=""/>
+        <p:cNvGrpSpPr/>
+        <p:nvPr/>
+      </p:nvGrpSpPr>
+      <p:grpSpPr>
+        <a:xfrm>
+          <a:off x="0" y="0"/>
+          <a:ext cx="0" cy="0"/>
+          <a:chOff x="0" y="0"/>
+          <a:chExt cx="0" cy="0"/>
+        </a:xfrm>
+      </p:grpSpPr>
+      <p:sp>
+        <p:nvSpPr>
+          <p:cNvPr id="2" name="Slide Image Placeholder 1"/>
+          <p:cNvSpPr>
+            <a:spLocks noGrp="1" noRot="1" noChangeAspect="1"/>
+          </p:cNvSpPr>
+          <p:nvPr>
+            <p:ph type="sldImg"/>
+          </p:nvPr>
+        </p:nvSpPr>
+        <p:spPr/>
+      </p:sp>
+      <p:sp>
+        <p:nvSpPr>
+          <p:cNvPr id="3" name="Notes Placeholder 2"/>
+          <p:cNvSpPr>
+            <a:spLocks noGrp="1"/>
+          </p:cNvSpPr>
+          <p:nvPr>
+            <p:ph type="body" idx="1"/>
+          </p:nvPr>
+        </p:nvSpPr>
+        <p:spPr/>
+        <p:txBody>
+          <a:bodyPr/>
+          <a:lstStyle/>
+          <a:p>
+            <a:r>
+              <a:rPr lang="en-US" dirty="0"/>
+              <a:t>A standard normal distribution has a  mean is 0 and the standard deviation is 1. 68% of all values should fall within 1 SD of the mean, 95% of all values should fall within 2 SD of the mean. Values under the tails of the distribution are highly unlikely! We can calculate p-values by plotting our observed value on simulated normally distributed data ( if H0 is true) to see what the probability of getting our observed data is if H0 is true. </a:t>
+            </a:r>
+          </a:p>
+          <a:p>
+            <a:r>
+              <a:rPr lang="en-US" dirty="0">
+                <a:solidFill>
+                  <a:srgbClr val="FFFFFF"/>
+                </a:solidFill>
+              </a:rPr>
+              <a:t>. It can be used to calculate the probability of a certain value’s distance from the mean via the z-score.</a:t>
+            </a:r>
+            <a:endParaRPr lang="en-US" dirty="0"/>
+          </a:p>
+          <a:p>
+            <a:endParaRPr lang="en-US" dirty="0"/>
+          </a:p>
+        </p:txBody>
+      </p:sp>
+      <p:sp>
+        <p:nvSpPr>
+          <p:cNvPr id="4" name="Slide Number Placeholder 3"/>
+          <p:cNvSpPr>
+            <a:spLocks noGrp="1"/>
+          </p:cNvSpPr>
+          <p:nvPr>
+            <p:ph type="sldNum" sz="quarter" idx="5"/>
+          </p:nvPr>
+        </p:nvSpPr>
+        <p:spPr/>
+        <p:txBody>
+          <a:bodyPr/>
+          <a:lstStyle/>
+          <a:p>
+            <a:fld id="{7DB159D7-3F9A-5C49-B0CF-E7444B3B457F}" type="slidenum">
+              <a:rPr lang="en-US" smtClean="0"/>
+              <a:t>3</a:t>
+            </a:fld>
+            <a:endParaRPr lang="en-US"/>
+          </a:p>
+        </p:txBody>
+      </p:sp>
+    </p:spTree>
+    <p:extLst>
+      <p:ext uri="{BB962C8B-B14F-4D97-AF65-F5344CB8AC3E}">
+        <p14:creationId xmlns:p14="http://schemas.microsoft.com/office/powerpoint/2010/main" val="1412741741"/>
+      </p:ext>
+    </p:extLst>
+  </p:cSld>
+  <p:clrMapOvr>
+    <a:masterClrMapping/>
+  </p:clrMapOvr>
+</p:notes>
+</file>
+
+<file path=ppt/notesSlides/notesSlide3.xml><?xml version="1.0" encoding="utf-8"?>
+<p:notes xmlns:a="http://schemas.openxmlformats.org/drawingml/2006/main" xmlns:r="http://schemas.openxmlformats.org/officeDocument/2006/relationships" xmlns:p="http://schemas.openxmlformats.org/presentationml/2006/main">
+  <p:cSld>
+    <p:spTree>
+      <p:nvGrpSpPr>
+        <p:cNvPr id="1" name=""/>
+        <p:cNvGrpSpPr/>
+        <p:nvPr/>
+      </p:nvGrpSpPr>
+      <p:grpSpPr>
+        <a:xfrm>
+          <a:off x="0" y="0"/>
+          <a:ext cx="0" cy="0"/>
+          <a:chOff x="0" y="0"/>
+          <a:chExt cx="0" cy="0"/>
+        </a:xfrm>
+      </p:grpSpPr>
+      <p:sp>
+        <p:nvSpPr>
+          <p:cNvPr id="2" name="Slide Image Placeholder 1"/>
+          <p:cNvSpPr>
+            <a:spLocks noGrp="1" noRot="1" noChangeAspect="1"/>
+          </p:cNvSpPr>
+          <p:nvPr>
+            <p:ph type="sldImg"/>
+          </p:nvPr>
+        </p:nvSpPr>
+        <p:spPr/>
+      </p:sp>
+      <p:sp>
+        <p:nvSpPr>
+          <p:cNvPr id="3" name="Notes Placeholder 2"/>
+          <p:cNvSpPr>
+            <a:spLocks noGrp="1"/>
+          </p:cNvSpPr>
+          <p:nvPr>
+            <p:ph type="body" idx="1"/>
+          </p:nvPr>
+        </p:nvSpPr>
+        <p:spPr/>
+        <p:txBody>
+          <a:bodyPr/>
+          <a:lstStyle/>
+          <a:p>
+            <a:r>
+              <a:rPr lang="en-US" dirty="0" err="1"/>
+              <a:t>Postiive</a:t>
+            </a:r>
+            <a:r>
+              <a:rPr lang="en-US" dirty="0"/>
+              <a:t> or right skewed data has a long tail to the right and negative or left skewed data has a long tail to the left. Note that in our skewed data we much different values that are less probably when compared to the </a:t>
+            </a:r>
+            <a:r>
+              <a:rPr lang="en-US" dirty="0" err="1"/>
+              <a:t>nomral</a:t>
+            </a:r>
+            <a:r>
+              <a:rPr lang="en-US" dirty="0"/>
+              <a:t> distribution. </a:t>
+            </a:r>
+            <a:r>
+              <a:rPr lang="en-US" dirty="0" err="1"/>
+              <a:t>Kurtosiss</a:t>
+            </a:r>
+            <a:r>
+              <a:rPr lang="en-US" dirty="0"/>
+              <a:t> is the measure of how the SD differs really, where slender distribution with long flat tails is called leptokurtic and a distribution that has short tails and a broad distribution is </a:t>
+            </a:r>
+            <a:r>
+              <a:rPr lang="en-US" dirty="0" err="1"/>
+              <a:t>lcalled</a:t>
+            </a:r>
+            <a:r>
+              <a:rPr lang="en-US" dirty="0"/>
+              <a:t> platykurtic. </a:t>
+            </a:r>
+          </a:p>
+        </p:txBody>
+      </p:sp>
+      <p:sp>
+        <p:nvSpPr>
+          <p:cNvPr id="4" name="Slide Number Placeholder 3"/>
+          <p:cNvSpPr>
+            <a:spLocks noGrp="1"/>
+          </p:cNvSpPr>
+          <p:nvPr>
+            <p:ph type="sldNum" sz="quarter" idx="5"/>
+          </p:nvPr>
+        </p:nvSpPr>
+        <p:spPr/>
+        <p:txBody>
+          <a:bodyPr/>
+          <a:lstStyle/>
+          <a:p>
+            <a:fld id="{7DB159D7-3F9A-5C49-B0CF-E7444B3B457F}" type="slidenum">
+              <a:rPr lang="en-US" smtClean="0"/>
+              <a:t>4</a:t>
+            </a:fld>
+            <a:endParaRPr lang="en-US"/>
+          </a:p>
+        </p:txBody>
+      </p:sp>
+    </p:spTree>
+    <p:extLst>
+      <p:ext uri="{BB962C8B-B14F-4D97-AF65-F5344CB8AC3E}">
+        <p14:creationId xmlns:p14="http://schemas.microsoft.com/office/powerpoint/2010/main" val="1616898590"/>
+      </p:ext>
+    </p:extLst>
+  </p:cSld>
+  <p:clrMapOvr>
+    <a:masterClrMapping/>
+  </p:clrMapOvr>
+</p:notes>
+</file>
+
+<file path=ppt/notesSlides/notesSlide4.xml><?xml version="1.0" encoding="utf-8"?>
+<p:notes xmlns:a="http://schemas.openxmlformats.org/drawingml/2006/main" xmlns:r="http://schemas.openxmlformats.org/officeDocument/2006/relationships" xmlns:p="http://schemas.openxmlformats.org/presentationml/2006/main">
+  <p:cSld>
+    <p:spTree>
+      <p:nvGrpSpPr>
+        <p:cNvPr id="1" name=""/>
+        <p:cNvGrpSpPr/>
+        <p:nvPr/>
+      </p:nvGrpSpPr>
+      <p:grpSpPr>
+        <a:xfrm>
+          <a:off x="0" y="0"/>
+          <a:ext cx="0" cy="0"/>
+          <a:chOff x="0" y="0"/>
+          <a:chExt cx="0" cy="0"/>
+        </a:xfrm>
+      </p:grpSpPr>
+      <p:sp>
+        <p:nvSpPr>
+          <p:cNvPr id="2" name="Slide Image Placeholder 1"/>
+          <p:cNvSpPr>
+            <a:spLocks noGrp="1" noRot="1" noChangeAspect="1"/>
+          </p:cNvSpPr>
+          <p:nvPr>
+            <p:ph type="sldImg"/>
+          </p:nvPr>
+        </p:nvSpPr>
+        <p:spPr/>
+      </p:sp>
+      <p:sp>
+        <p:nvSpPr>
+          <p:cNvPr id="3" name="Notes Placeholder 2"/>
+          <p:cNvSpPr>
+            <a:spLocks noGrp="1"/>
+          </p:cNvSpPr>
+          <p:nvPr>
+            <p:ph type="body" idx="1"/>
+          </p:nvPr>
+        </p:nvSpPr>
+        <p:spPr/>
+        <p:txBody>
+          <a:bodyPr/>
+          <a:lstStyle/>
+          <a:p>
+            <a:r>
+              <a:rPr lang="en-US" dirty="0"/>
+              <a:t>We use ln() natural log in r instead of log10 because it is standard practice, easier to back transform and easier to scale. </a:t>
+            </a:r>
+          </a:p>
+        </p:txBody>
+      </p:sp>
+      <p:sp>
+        <p:nvSpPr>
+          <p:cNvPr id="4" name="Slide Number Placeholder 3"/>
+          <p:cNvSpPr>
+            <a:spLocks noGrp="1"/>
+          </p:cNvSpPr>
+          <p:nvPr>
+            <p:ph type="sldNum" sz="quarter" idx="5"/>
+          </p:nvPr>
+        </p:nvSpPr>
+        <p:spPr/>
+        <p:txBody>
+          <a:bodyPr/>
+          <a:lstStyle/>
+          <a:p>
+            <a:fld id="{7DB159D7-3F9A-5C49-B0CF-E7444B3B457F}" type="slidenum">
+              <a:rPr lang="en-US" smtClean="0"/>
+              <a:t>6</a:t>
+            </a:fld>
+            <a:endParaRPr lang="en-US"/>
+          </a:p>
+        </p:txBody>
+      </p:sp>
+    </p:spTree>
+    <p:extLst>
+      <p:ext uri="{BB962C8B-B14F-4D97-AF65-F5344CB8AC3E}">
+        <p14:creationId xmlns:p14="http://schemas.microsoft.com/office/powerpoint/2010/main" val="43732012"/>
+      </p:ext>
+    </p:extLst>
+  </p:cSld>
+  <p:clrMapOvr>
+    <a:masterClrMapping/>
+  </p:clrMapOvr>
+</p:notes>
+</file>
+
+<file path=ppt/notesSlides/notesSlide5.xml><?xml version="1.0" encoding="utf-8"?>
+<p:notes xmlns:a="http://schemas.openxmlformats.org/drawingml/2006/main" xmlns:r="http://schemas.openxmlformats.org/officeDocument/2006/relationships" xmlns:p="http://schemas.openxmlformats.org/presentationml/2006/main">
+  <p:cSld>
+    <p:spTree>
+      <p:nvGrpSpPr>
+        <p:cNvPr id="1" name=""/>
+        <p:cNvGrpSpPr/>
+        <p:nvPr/>
+      </p:nvGrpSpPr>
+      <p:grpSpPr>
+        <a:xfrm>
+          <a:off x="0" y="0"/>
+          <a:ext cx="0" cy="0"/>
+          <a:chOff x="0" y="0"/>
+          <a:chExt cx="0" cy="0"/>
+        </a:xfrm>
+      </p:grpSpPr>
+      <p:sp>
+        <p:nvSpPr>
+          <p:cNvPr id="2" name="Slide Image Placeholder 1"/>
+          <p:cNvSpPr>
+            <a:spLocks noGrp="1" noRot="1" noChangeAspect="1"/>
+          </p:cNvSpPr>
+          <p:nvPr>
+            <p:ph type="sldImg"/>
+          </p:nvPr>
+        </p:nvSpPr>
+        <p:spPr/>
+      </p:sp>
+      <p:sp>
+        <p:nvSpPr>
+          <p:cNvPr id="3" name="Notes Placeholder 2"/>
+          <p:cNvSpPr>
+            <a:spLocks noGrp="1"/>
+          </p:cNvSpPr>
+          <p:nvPr>
+            <p:ph type="body" idx="1"/>
+          </p:nvPr>
+        </p:nvSpPr>
+        <p:spPr/>
+        <p:txBody>
+          <a:bodyPr/>
+          <a:lstStyle/>
+          <a:p>
+            <a:r>
+              <a:rPr lang="en-US" dirty="0"/>
+              <a:t>Q-Q plots show you how much your data deviates from the normal distribution. If your data aligns perfectly with the normal distribution, the points will fall along the line. </a:t>
+            </a:r>
+            <a:r>
+              <a:rPr lang="en-US" sz="1200" b="0" i="0" kern="1200" dirty="0">
+                <a:solidFill>
+                  <a:schemeClr val="tx1"/>
+                </a:solidFill>
+                <a:effectLst/>
+                <a:latin typeface="+mn-lt"/>
+                <a:ea typeface="+mn-ea"/>
+                <a:cs typeface="+mn-cs"/>
+              </a:rPr>
+              <a:t> A Q-Q (quantile-quantile) plot compares your data’s distribution against a theoretical normal distribution. If your data is normal, the points fall along a straight diagonal line. Right-skewed data produces a curve that bows away from the line. Heavy-tailed data (more extreme values than expected) follows the line in the middle but curves off at both ends.</a:t>
+            </a:r>
+          </a:p>
+          <a:p>
+            <a:endParaRPr lang="en-US" dirty="0"/>
+          </a:p>
+          <a:p>
+            <a:r>
+              <a:rPr lang="en-US" dirty="0"/>
+              <a:t>- Shapiro-wilks test - outputs can be sensitive to your sample size, more likely to fail </a:t>
+            </a:r>
+            <a:r>
+              <a:rPr lang="en-US" dirty="0" err="1"/>
+              <a:t>shapiro</a:t>
+            </a:r>
+            <a:r>
+              <a:rPr lang="en-US" dirty="0"/>
+              <a:t>-wilks test when you have large sample sizes. </a:t>
+            </a:r>
+          </a:p>
+          <a:p>
+            <a:r>
+              <a:rPr lang="en-US" dirty="0"/>
+              <a:t>- doesn't tell you what's wrong</a:t>
+            </a:r>
+          </a:p>
+          <a:p>
+            <a:r>
+              <a:rPr lang="en-US" dirty="0"/>
+              <a:t>- is your error distribution problematic or non-problematic</a:t>
+            </a:r>
+          </a:p>
+          <a:p>
+            <a:r>
+              <a:rPr lang="en-US" dirty="0"/>
+              <a:t>-  outlier removal...  is it biological or is it bad data? or bad methods?</a:t>
+            </a:r>
+          </a:p>
+          <a:p>
+            <a:r>
+              <a:rPr lang="en-US" dirty="0"/>
+              <a:t>-  remove </a:t>
+            </a:r>
+            <a:r>
+              <a:rPr lang="en-US" dirty="0" err="1"/>
+              <a:t>outilier</a:t>
+            </a:r>
+            <a:r>
+              <a:rPr lang="en-US" dirty="0"/>
+              <a:t> and run model, add outlier and run model</a:t>
+            </a:r>
+          </a:p>
+          <a:p>
+            <a:r>
+              <a:rPr lang="en-US" dirty="0"/>
+              <a:t>- platykurtic data will have an s-shaped curve on the QQ plot, r shape or j shape BAD</a:t>
+            </a:r>
+          </a:p>
+          <a:p>
+            <a:r>
+              <a:rPr lang="en-US" dirty="0"/>
+              <a:t>- </a:t>
+            </a:r>
+          </a:p>
+          <a:p>
+            <a:r>
+              <a:rPr lang="en-US" dirty="0"/>
+              <a:t>- distribution of raw response variable doesn't matter</a:t>
+            </a:r>
+            <a:br>
+              <a:rPr lang="en-US" dirty="0"/>
+            </a:br>
+            <a:r>
+              <a:rPr lang="en-US" dirty="0"/>
+              <a:t>- can also use a Shapiro-wilk test to test for normality. </a:t>
+            </a:r>
+          </a:p>
+        </p:txBody>
+      </p:sp>
+      <p:sp>
+        <p:nvSpPr>
+          <p:cNvPr id="4" name="Slide Number Placeholder 3"/>
+          <p:cNvSpPr>
+            <a:spLocks noGrp="1"/>
+          </p:cNvSpPr>
+          <p:nvPr>
+            <p:ph type="sldNum" sz="quarter" idx="5"/>
+          </p:nvPr>
+        </p:nvSpPr>
+        <p:spPr/>
+        <p:txBody>
+          <a:bodyPr/>
+          <a:lstStyle/>
+          <a:p>
+            <a:fld id="{7DB159D7-3F9A-5C49-B0CF-E7444B3B457F}" type="slidenum">
+              <a:rPr lang="en-US" smtClean="0"/>
+              <a:t>7</a:t>
+            </a:fld>
+            <a:endParaRPr lang="en-US"/>
+          </a:p>
+        </p:txBody>
+      </p:sp>
+    </p:spTree>
+    <p:extLst>
+      <p:ext uri="{BB962C8B-B14F-4D97-AF65-F5344CB8AC3E}">
+        <p14:creationId xmlns:p14="http://schemas.microsoft.com/office/powerpoint/2010/main" val="720027104"/>
+      </p:ext>
+    </p:extLst>
+  </p:cSld>
+  <p:clrMapOvr>
+    <a:masterClrMapping/>
+  </p:clrMapOvr>
+</p:notes>
+</file>
+
+<file path=ppt/notesSlides/notesSlide6.xml><?xml version="1.0" encoding="utf-8"?>
+<p:notes xmlns:a="http://schemas.openxmlformats.org/drawingml/2006/main" xmlns:r="http://schemas.openxmlformats.org/officeDocument/2006/relationships" xmlns:p="http://schemas.openxmlformats.org/presentationml/2006/main">
+  <p:cSld>
+    <p:spTree>
+      <p:nvGrpSpPr>
+        <p:cNvPr id="1" name=""/>
+        <p:cNvGrpSpPr/>
+        <p:nvPr/>
+      </p:nvGrpSpPr>
+      <p:grpSpPr>
+        <a:xfrm>
+          <a:off x="0" y="0"/>
+          <a:ext cx="0" cy="0"/>
+          <a:chOff x="0" y="0"/>
+          <a:chExt cx="0" cy="0"/>
+        </a:xfrm>
+      </p:grpSpPr>
+      <p:sp>
+        <p:nvSpPr>
+          <p:cNvPr id="2" name="Slide Image Placeholder 1"/>
+          <p:cNvSpPr>
+            <a:spLocks noGrp="1" noRot="1" noChangeAspect="1"/>
+          </p:cNvSpPr>
+          <p:nvPr>
+            <p:ph type="sldImg"/>
+          </p:nvPr>
+        </p:nvSpPr>
+        <p:spPr/>
+      </p:sp>
+      <p:sp>
+        <p:nvSpPr>
+          <p:cNvPr id="3" name="Notes Placeholder 2"/>
+          <p:cNvSpPr>
+            <a:spLocks noGrp="1"/>
+          </p:cNvSpPr>
+          <p:nvPr>
+            <p:ph type="body" idx="1"/>
+          </p:nvPr>
+        </p:nvSpPr>
+        <p:spPr/>
+        <p:txBody>
+          <a:bodyPr/>
+          <a:lstStyle/>
+          <a:p>
+            <a:r>
+              <a:rPr lang="en-US" dirty="0"/>
+              <a:t>- absolute lambda is less important than if its </a:t>
+            </a:r>
+            <a:r>
+              <a:rPr lang="en-US" dirty="0" err="1"/>
+              <a:t>postive</a:t>
+            </a:r>
+            <a:r>
+              <a:rPr lang="en-US" dirty="0"/>
+              <a:t> or negative.</a:t>
+            </a:r>
+          </a:p>
+          <a:p>
+            <a:r>
+              <a:rPr lang="en-US" dirty="0"/>
+              <a:t>- </a:t>
+            </a:r>
+            <a:r>
+              <a:rPr lang="en-US" dirty="0" err="1"/>
+              <a:t>postive</a:t>
+            </a:r>
+            <a:r>
+              <a:rPr lang="en-US" dirty="0"/>
+              <a:t> lambda apply log function</a:t>
+            </a:r>
+          </a:p>
+          <a:p>
+            <a:r>
+              <a:rPr lang="en-US" dirty="0"/>
+              <a:t>- negative lambda apply sqrt </a:t>
+            </a:r>
+          </a:p>
+          <a:p>
+            <a:r>
+              <a:rPr lang="en-US" dirty="0"/>
+              <a:t>- </a:t>
+            </a:r>
+            <a:r>
+              <a:rPr lang="en-US" dirty="0" err="1"/>
+              <a:t>boxcox</a:t>
+            </a:r>
+            <a:r>
+              <a:rPr lang="en-US" dirty="0"/>
+              <a:t> figures out what is best by shrinking small values to </a:t>
+            </a:r>
+            <a:r>
+              <a:rPr lang="en-US" dirty="0" err="1"/>
+              <a:t>shrinnking</a:t>
+            </a:r>
+            <a:r>
+              <a:rPr lang="en-US" dirty="0"/>
+              <a:t> large value, which one looks more normal.</a:t>
+            </a:r>
+          </a:p>
+          <a:p>
+            <a:r>
+              <a:rPr lang="en-US" dirty="0"/>
+              <a:t>- </a:t>
+            </a:r>
+          </a:p>
+        </p:txBody>
+      </p:sp>
+      <p:sp>
+        <p:nvSpPr>
+          <p:cNvPr id="4" name="Slide Number Placeholder 3"/>
+          <p:cNvSpPr>
+            <a:spLocks noGrp="1"/>
+          </p:cNvSpPr>
+          <p:nvPr>
+            <p:ph type="sldNum" sz="quarter" idx="5"/>
+          </p:nvPr>
+        </p:nvSpPr>
+        <p:spPr/>
+        <p:txBody>
+          <a:bodyPr/>
+          <a:lstStyle/>
+          <a:p>
+            <a:fld id="{7DB159D7-3F9A-5C49-B0CF-E7444B3B457F}" type="slidenum">
+              <a:rPr lang="en-US" smtClean="0"/>
+              <a:t>8</a:t>
+            </a:fld>
+            <a:endParaRPr lang="en-US"/>
+          </a:p>
+        </p:txBody>
+      </p:sp>
+    </p:spTree>
+    <p:extLst>
+      <p:ext uri="{BB962C8B-B14F-4D97-AF65-F5344CB8AC3E}">
+        <p14:creationId xmlns:p14="http://schemas.microsoft.com/office/powerpoint/2010/main" val="2781368425"/>
+      </p:ext>
+    </p:extLst>
+  </p:cSld>
+  <p:clrMapOvr>
+    <a:masterClrMapping/>
+  </p:clrMapOvr>
+</p:notes>
+</file>
+
+<file path=ppt/notesSlides/notesSlide7.xml><?xml version="1.0" encoding="utf-8"?>
+<p:notes xmlns:a="http://schemas.openxmlformats.org/drawingml/2006/main" xmlns:r="http://schemas.openxmlformats.org/officeDocument/2006/relationships" xmlns:p="http://schemas.openxmlformats.org/presentationml/2006/main">
+  <p:cSld>
+    <p:spTree>
+      <p:nvGrpSpPr>
+        <p:cNvPr id="1" name=""/>
+        <p:cNvGrpSpPr/>
+        <p:nvPr/>
+      </p:nvGrpSpPr>
+      <p:grpSpPr>
+        <a:xfrm>
+          <a:off x="0" y="0"/>
+          <a:ext cx="0" cy="0"/>
+          <a:chOff x="0" y="0"/>
+          <a:chExt cx="0" cy="0"/>
+        </a:xfrm>
+      </p:grpSpPr>
+      <p:sp>
+        <p:nvSpPr>
+          <p:cNvPr id="2" name="Slide Image Placeholder 1"/>
+          <p:cNvSpPr>
+            <a:spLocks noGrp="1" noRot="1" noChangeAspect="1"/>
+          </p:cNvSpPr>
+          <p:nvPr>
+            <p:ph type="sldImg"/>
+          </p:nvPr>
+        </p:nvSpPr>
+        <p:spPr/>
+      </p:sp>
+      <p:sp>
+        <p:nvSpPr>
+          <p:cNvPr id="3" name="Notes Placeholder 2"/>
+          <p:cNvSpPr>
+            <a:spLocks noGrp="1"/>
+          </p:cNvSpPr>
+          <p:nvPr>
+            <p:ph type="body" idx="1"/>
+          </p:nvPr>
+        </p:nvSpPr>
+        <p:spPr/>
+        <p:txBody>
+          <a:bodyPr/>
+          <a:lstStyle/>
+          <a:p>
+            <a:r>
+              <a:rPr lang="en-US" dirty="0"/>
+              <a:t>- if you have zero-inflated data, hurdle model , </a:t>
+            </a:r>
+            <a:r>
+              <a:rPr lang="en-US" dirty="0" err="1"/>
+              <a:t>poisson</a:t>
+            </a:r>
+            <a:r>
+              <a:rPr lang="en-US" dirty="0"/>
+              <a:t> model</a:t>
+            </a:r>
+          </a:p>
+          <a:p>
+            <a:r>
+              <a:rPr lang="en-US" dirty="0"/>
+              <a:t>-  really changing half  your dataset, </a:t>
+            </a:r>
+          </a:p>
+          <a:p>
+            <a:r>
+              <a:rPr lang="en-US" dirty="0"/>
+              <a:t>- could shift your data </a:t>
+            </a:r>
+          </a:p>
+          <a:p>
+            <a:r>
+              <a:rPr lang="en-US" dirty="0"/>
+              <a:t>- linear </a:t>
+            </a:r>
+            <a:r>
+              <a:rPr lang="en-US" dirty="0" err="1"/>
+              <a:t>transformatino</a:t>
+            </a:r>
+            <a:r>
+              <a:rPr lang="en-US" dirty="0"/>
+              <a:t> doesn't change the intercept model </a:t>
+            </a:r>
+          </a:p>
+        </p:txBody>
+      </p:sp>
+      <p:sp>
+        <p:nvSpPr>
+          <p:cNvPr id="4" name="Slide Number Placeholder 3"/>
+          <p:cNvSpPr>
+            <a:spLocks noGrp="1"/>
+          </p:cNvSpPr>
+          <p:nvPr>
+            <p:ph type="sldNum" sz="quarter" idx="5"/>
+          </p:nvPr>
+        </p:nvSpPr>
+        <p:spPr/>
+        <p:txBody>
+          <a:bodyPr/>
+          <a:lstStyle/>
+          <a:p>
+            <a:fld id="{7DB159D7-3F9A-5C49-B0CF-E7444B3B457F}" type="slidenum">
+              <a:rPr lang="en-US" smtClean="0"/>
+              <a:t>9</a:t>
+            </a:fld>
+            <a:endParaRPr lang="en-US"/>
+          </a:p>
+        </p:txBody>
+      </p:sp>
+    </p:spTree>
+    <p:extLst>
+      <p:ext uri="{BB962C8B-B14F-4D97-AF65-F5344CB8AC3E}">
+        <p14:creationId xmlns:p14="http://schemas.microsoft.com/office/powerpoint/2010/main" val="3819218657"/>
+      </p:ext>
+    </p:extLst>
+  </p:cSld>
+  <p:clrMapOvr>
+    <a:masterClrMapping/>
+  </p:clrMapOvr>
+</p:notes>
+</file>
+
+<file path=ppt/notesSlides/notesSlide8.xml><?xml version="1.0" encoding="utf-8"?>
+<p:notes xmlns:a="http://schemas.openxmlformats.org/drawingml/2006/main" xmlns:r="http://schemas.openxmlformats.org/officeDocument/2006/relationships" xmlns:p="http://schemas.openxmlformats.org/presentationml/2006/main">
+  <p:cSld>
+    <p:spTree>
+      <p:nvGrpSpPr>
+        <p:cNvPr id="1" name=""/>
+        <p:cNvGrpSpPr/>
+        <p:nvPr/>
+      </p:nvGrpSpPr>
+      <p:grpSpPr>
+        <a:xfrm>
+          <a:off x="0" y="0"/>
+          <a:ext cx="0" cy="0"/>
+          <a:chOff x="0" y="0"/>
+          <a:chExt cx="0" cy="0"/>
+        </a:xfrm>
+      </p:grpSpPr>
+      <p:sp>
+        <p:nvSpPr>
+          <p:cNvPr id="2" name="Slide Image Placeholder 1"/>
+          <p:cNvSpPr>
+            <a:spLocks noGrp="1" noRot="1" noChangeAspect="1"/>
+          </p:cNvSpPr>
+          <p:nvPr>
+            <p:ph type="sldImg"/>
+          </p:nvPr>
+        </p:nvSpPr>
+        <p:spPr/>
+      </p:sp>
+      <p:sp>
+        <p:nvSpPr>
+          <p:cNvPr id="3" name="Notes Placeholder 2"/>
+          <p:cNvSpPr>
+            <a:spLocks noGrp="1"/>
+          </p:cNvSpPr>
+          <p:nvPr>
+            <p:ph type="body" idx="1"/>
+          </p:nvPr>
+        </p:nvSpPr>
+        <p:spPr/>
+        <p:txBody>
+          <a:bodyPr/>
+          <a:lstStyle/>
+          <a:p>
+            <a:r>
+              <a:rPr lang="en-US" dirty="0"/>
+              <a:t>Nonparametric regression refers to a class of regression techniques that do not assume a specific functional form for the relationship between a predictor and a response. It allows the data to speak for itself</a:t>
+            </a:r>
+          </a:p>
+        </p:txBody>
+      </p:sp>
+      <p:sp>
+        <p:nvSpPr>
+          <p:cNvPr id="4" name="Slide Number Placeholder 3"/>
+          <p:cNvSpPr>
+            <a:spLocks noGrp="1"/>
+          </p:cNvSpPr>
+          <p:nvPr>
+            <p:ph type="sldNum" sz="quarter" idx="5"/>
+          </p:nvPr>
+        </p:nvSpPr>
+        <p:spPr/>
+        <p:txBody>
+          <a:bodyPr/>
+          <a:lstStyle/>
+          <a:p>
+            <a:fld id="{7DB159D7-3F9A-5C49-B0CF-E7444B3B457F}" type="slidenum">
+              <a:rPr lang="en-US" smtClean="0"/>
+              <a:t>11</a:t>
+            </a:fld>
+            <a:endParaRPr lang="en-US"/>
+          </a:p>
+        </p:txBody>
+      </p:sp>
+    </p:spTree>
+    <p:extLst>
+      <p:ext uri="{BB962C8B-B14F-4D97-AF65-F5344CB8AC3E}">
+        <p14:creationId xmlns:p14="http://schemas.microsoft.com/office/powerpoint/2010/main" val="3683024633"/>
+      </p:ext>
+    </p:extLst>
+  </p:cSld>
+  <p:clrMapOvr>
+    <a:masterClrMapping/>
+  </p:clrMapOvr>
+</p:notes>
+</file>
+
+<file path=ppt/notesSlides/notesSlide9.xml><?xml version="1.0" encoding="utf-8"?>
+<p:notes xmlns:a="http://schemas.openxmlformats.org/drawingml/2006/main" xmlns:r="http://schemas.openxmlformats.org/officeDocument/2006/relationships" xmlns:p="http://schemas.openxmlformats.org/presentationml/2006/main">
+  <p:cSld>
+    <p:spTree>
+      <p:nvGrpSpPr>
+        <p:cNvPr id="1" name=""/>
+        <p:cNvGrpSpPr/>
+        <p:nvPr/>
+      </p:nvGrpSpPr>
+      <p:grpSpPr>
+        <a:xfrm>
+          <a:off x="0" y="0"/>
+          <a:ext cx="0" cy="0"/>
+          <a:chOff x="0" y="0"/>
+          <a:chExt cx="0" cy="0"/>
+        </a:xfrm>
+      </p:grpSpPr>
+      <p:sp>
+        <p:nvSpPr>
+          <p:cNvPr id="2" name="Slide Image Placeholder 1"/>
+          <p:cNvSpPr>
+            <a:spLocks noGrp="1" noRot="1" noChangeAspect="1"/>
+          </p:cNvSpPr>
+          <p:nvPr>
+            <p:ph type="sldImg"/>
+          </p:nvPr>
+        </p:nvSpPr>
+        <p:spPr/>
+      </p:sp>
+      <p:sp>
+        <p:nvSpPr>
+          <p:cNvPr id="3" name="Notes Placeholder 2"/>
+          <p:cNvSpPr>
+            <a:spLocks noGrp="1"/>
+          </p:cNvSpPr>
+          <p:nvPr>
+            <p:ph type="body" idx="1"/>
+          </p:nvPr>
+        </p:nvSpPr>
+        <p:spPr/>
+        <p:txBody>
+          <a:bodyPr/>
+          <a:lstStyle/>
+          <a:p>
+            <a:r>
+              <a:rPr lang="en-US" dirty="0"/>
+              <a:t>Likelihood ratio test  compare the goodness of fir between two models </a:t>
+            </a:r>
+          </a:p>
+          <a:p>
+            <a:endParaRPr lang="en-US" dirty="0"/>
+          </a:p>
+          <a:p>
+            <a:r>
+              <a:rPr lang="en-US" dirty="0" err="1"/>
+              <a:t>poisson</a:t>
+            </a:r>
+            <a:r>
+              <a:rPr lang="en-US" dirty="0"/>
+              <a:t> = mean = variance</a:t>
+            </a:r>
+          </a:p>
+          <a:p>
+            <a:endParaRPr lang="en-US" dirty="0"/>
+          </a:p>
+          <a:p>
+            <a:r>
+              <a:rPr lang="en-US" dirty="0"/>
+              <a:t>negative binomial =  variance &gt; mean </a:t>
+            </a:r>
+          </a:p>
+          <a:p>
+            <a:endParaRPr lang="en-US" dirty="0"/>
+          </a:p>
+          <a:p>
+            <a:endParaRPr lang="en-US" dirty="0"/>
+          </a:p>
+        </p:txBody>
+      </p:sp>
+      <p:sp>
+        <p:nvSpPr>
+          <p:cNvPr id="4" name="Slide Number Placeholder 3"/>
+          <p:cNvSpPr>
+            <a:spLocks noGrp="1"/>
+          </p:cNvSpPr>
+          <p:nvPr>
+            <p:ph type="sldNum" sz="quarter" idx="5"/>
+          </p:nvPr>
+        </p:nvSpPr>
+        <p:spPr/>
+        <p:txBody>
+          <a:bodyPr/>
+          <a:lstStyle/>
+          <a:p>
+            <a:fld id="{7DB159D7-3F9A-5C49-B0CF-E7444B3B457F}" type="slidenum">
+              <a:rPr lang="en-US" smtClean="0"/>
+              <a:t>12</a:t>
+            </a:fld>
+            <a:endParaRPr lang="en-US"/>
+          </a:p>
+        </p:txBody>
+      </p:sp>
+    </p:spTree>
+    <p:extLst>
+      <p:ext uri="{BB962C8B-B14F-4D97-AF65-F5344CB8AC3E}">
+        <p14:creationId xmlns:p14="http://schemas.microsoft.com/office/powerpoint/2010/main" val="225103600"/>
       </p:ext>
     </p:extLst>
   </p:cSld>
@@ -8690,7 +9219,7 @@
           <a:p>
             <a:fld id="{F0D8010B-F27E-5D41-AB64-65E1DB7962E6}" type="datetimeFigureOut">
               <a:rPr lang="en-US" smtClean="0"/>
-              <a:t>10/20/26</a:t>
+              <a:t>10/21/26</a:t>
             </a:fld>
             <a:endParaRPr lang="en-US"/>
           </a:p>
@@ -9781,7 +10310,7 @@
           <a:p>
             <a:fld id="{F0D8010B-F27E-5D41-AB64-65E1DB7962E6}" type="datetimeFigureOut">
               <a:rPr lang="en-US" smtClean="0"/>
-              <a:t>10/20/26</a:t>
+              <a:t>10/21/26</a:t>
             </a:fld>
             <a:endParaRPr lang="en-US"/>
           </a:p>
@@ -10761,7 +11290,7 @@
           <a:p>
             <a:fld id="{F0D8010B-F27E-5D41-AB64-65E1DB7962E6}" type="datetimeFigureOut">
               <a:rPr lang="en-US" smtClean="0"/>
-              <a:t>10/20/26</a:t>
+              <a:t>10/21/26</a:t>
             </a:fld>
             <a:endParaRPr lang="en-US"/>
           </a:p>
@@ -11895,7 +12424,7 @@
           <a:p>
             <a:fld id="{F0D8010B-F27E-5D41-AB64-65E1DB7962E6}" type="datetimeFigureOut">
               <a:rPr lang="en-US" smtClean="0"/>
-              <a:t>10/20/26</a:t>
+              <a:t>10/21/26</a:t>
             </a:fld>
             <a:endParaRPr lang="en-US"/>
           </a:p>
@@ -12928,7 +13457,7 @@
           <a:p>
             <a:fld id="{F0D8010B-F27E-5D41-AB64-65E1DB7962E6}" type="datetimeFigureOut">
               <a:rPr lang="en-US" smtClean="0"/>
-              <a:t>10/20/26</a:t>
+              <a:t>10/21/26</a:t>
             </a:fld>
             <a:endParaRPr lang="en-US"/>
           </a:p>
@@ -13588,7 +14117,7 @@
           <a:p>
             <a:fld id="{F0D8010B-F27E-5D41-AB64-65E1DB7962E6}" type="datetimeFigureOut">
               <a:rPr lang="en-US" smtClean="0"/>
-              <a:t>10/20/26</a:t>
+              <a:t>10/21/26</a:t>
             </a:fld>
             <a:endParaRPr lang="en-US"/>
           </a:p>
@@ -14437,7 +14966,7 @@
           <a:p>
             <a:fld id="{F0D8010B-F27E-5D41-AB64-65E1DB7962E6}" type="datetimeFigureOut">
               <a:rPr lang="en-US" smtClean="0"/>
-              <a:t>10/20/26</a:t>
+              <a:t>10/21/26</a:t>
             </a:fld>
             <a:endParaRPr lang="en-US"/>
           </a:p>
@@ -14627,7 +15156,7 @@
           <a:p>
             <a:fld id="{F0D8010B-F27E-5D41-AB64-65E1DB7962E6}" type="datetimeFigureOut">
               <a:rPr lang="en-US" smtClean="0"/>
-              <a:t>10/20/26</a:t>
+              <a:t>10/21/26</a:t>
             </a:fld>
             <a:endParaRPr lang="en-US"/>
           </a:p>
@@ -15599,7 +16128,7 @@
           <a:p>
             <a:fld id="{F0D8010B-F27E-5D41-AB64-65E1DB7962E6}" type="datetimeFigureOut">
               <a:rPr lang="en-US" smtClean="0"/>
-              <a:t>10/20/26</a:t>
+              <a:t>10/21/26</a:t>
             </a:fld>
             <a:endParaRPr lang="en-US"/>
           </a:p>
@@ -15810,7 +16339,7 @@
           <a:p>
             <a:fld id="{F0D8010B-F27E-5D41-AB64-65E1DB7962E6}" type="datetimeFigureOut">
               <a:rPr lang="en-US" smtClean="0"/>
-              <a:t>10/20/26</a:t>
+              <a:t>10/21/26</a:t>
             </a:fld>
             <a:endParaRPr lang="en-US"/>
           </a:p>
@@ -16844,7 +17373,7 @@
           <a:p>
             <a:fld id="{F0D8010B-F27E-5D41-AB64-65E1DB7962E6}" type="datetimeFigureOut">
               <a:rPr lang="en-US" smtClean="0"/>
-              <a:t>10/20/26</a:t>
+              <a:t>10/21/26</a:t>
             </a:fld>
             <a:endParaRPr lang="en-US"/>
           </a:p>
@@ -17116,7 +17645,7 @@
           <a:p>
             <a:fld id="{F0D8010B-F27E-5D41-AB64-65E1DB7962E6}" type="datetimeFigureOut">
               <a:rPr lang="en-US" smtClean="0"/>
-              <a:t>10/20/26</a:t>
+              <a:t>10/21/26</a:t>
             </a:fld>
             <a:endParaRPr lang="en-US"/>
           </a:p>
@@ -17526,7 +18055,7 @@
           <a:p>
             <a:fld id="{F0D8010B-F27E-5D41-AB64-65E1DB7962E6}" type="datetimeFigureOut">
               <a:rPr lang="en-US" smtClean="0"/>
-              <a:t>10/20/26</a:t>
+              <a:t>10/21/26</a:t>
             </a:fld>
             <a:endParaRPr lang="en-US"/>
           </a:p>
@@ -17653,7 +18182,7 @@
           <a:p>
             <a:fld id="{F0D8010B-F27E-5D41-AB64-65E1DB7962E6}" type="datetimeFigureOut">
               <a:rPr lang="en-US" smtClean="0"/>
-              <a:t>10/20/26</a:t>
+              <a:t>10/21/26</a:t>
             </a:fld>
             <a:endParaRPr lang="en-US"/>
           </a:p>
@@ -17748,7 +18277,7 @@
           <a:p>
             <a:fld id="{F0D8010B-F27E-5D41-AB64-65E1DB7962E6}" type="datetimeFigureOut">
               <a:rPr lang="en-US" smtClean="0"/>
-              <a:t>10/20/26</a:t>
+              <a:t>10/21/26</a:t>
             </a:fld>
             <a:endParaRPr lang="en-US"/>
           </a:p>
@@ -18836,7 +19365,7 @@
           <a:p>
             <a:fld id="{F0D8010B-F27E-5D41-AB64-65E1DB7962E6}" type="datetimeFigureOut">
               <a:rPr lang="en-US" smtClean="0"/>
-              <a:t>10/20/26</a:t>
+              <a:t>10/21/26</a:t>
             </a:fld>
             <a:endParaRPr lang="en-US"/>
           </a:p>
@@ -19940,7 +20469,7 @@
           <a:p>
             <a:fld id="{F0D8010B-F27E-5D41-AB64-65E1DB7962E6}" type="datetimeFigureOut">
               <a:rPr lang="en-US" smtClean="0"/>
-              <a:t>10/20/26</a:t>
+              <a:t>10/21/26</a:t>
             </a:fld>
             <a:endParaRPr lang="en-US"/>
           </a:p>
@@ -21000,7 +21529,7 @@
           <a:p>
             <a:fld id="{F0D8010B-F27E-5D41-AB64-65E1DB7962E6}" type="datetimeFigureOut">
               <a:rPr lang="en-US" smtClean="0"/>
-              <a:t>10/20/26</a:t>
+              <a:t>10/21/26</a:t>
             </a:fld>
             <a:endParaRPr lang="en-US"/>
           </a:p>
@@ -22450,15 +22979,15 @@
           <p:nvPr/>
         </p:nvPicPr>
         <p:blipFill>
-          <a:blip r:embed="rId2"/>
+          <a:blip r:embed="rId3"/>
           <a:stretch>
             <a:fillRect/>
           </a:stretch>
         </p:blipFill>
         <p:spPr>
           <a:xfrm>
-            <a:off x="5194607" y="1631382"/>
-            <a:ext cx="6391533" cy="3595236"/>
+            <a:off x="4842982" y="1394847"/>
+            <a:ext cx="7163665" cy="4029560"/>
           </a:xfrm>
           <a:prstGeom prst="rect">
             <a:avLst/>
@@ -22705,15 +23234,27 @@
         </p:nvSpPr>
         <p:spPr>
           <a:xfrm>
-            <a:off x="1154955" y="2120900"/>
-            <a:ext cx="3133726" cy="3898900"/>
+            <a:off x="948268" y="2120900"/>
+            <a:ext cx="3498140" cy="3898900"/>
           </a:xfrm>
         </p:spPr>
         <p:txBody>
           <a:bodyPr>
-            <a:normAutofit/>
+            <a:normAutofit fontScale="92500" lnSpcReduction="20000"/>
           </a:bodyPr>
           <a:lstStyle/>
+          <a:p>
+            <a:pPr>
+              <a:lnSpc>
+                <a:spcPct val="90000"/>
+              </a:lnSpc>
+            </a:pPr>
+            <a:endParaRPr lang="en-US" sz="1500" dirty="0">
+              <a:solidFill>
+                <a:srgbClr val="FFFFFF"/>
+              </a:solidFill>
+            </a:endParaRPr>
+          </a:p>
           <a:p>
             <a:pPr>
               <a:lnSpc>
@@ -22721,12 +23262,57 @@
               </a:lnSpc>
             </a:pPr>
             <a:r>
-              <a:rPr lang="en-US" sz="1500">
+              <a:rPr lang="en-US" sz="1500" dirty="0">
                 <a:solidFill>
                   <a:srgbClr val="FFFFFF"/>
                 </a:solidFill>
               </a:rPr>
-              <a:t> Distribution Families</a:t>
+              <a:t>Kernel Regression – estimated by weighted average of nearby data points</a:t>
+            </a:r>
+          </a:p>
+          <a:p>
+            <a:pPr>
+              <a:lnSpc>
+                <a:spcPct val="90000"/>
+              </a:lnSpc>
+            </a:pPr>
+            <a:r>
+              <a:rPr lang="en-US" sz="1500" dirty="0">
+                <a:solidFill>
+                  <a:srgbClr val="FFFFFF"/>
+                </a:solidFill>
+              </a:rPr>
+              <a:t>Smoothing Splines – fits a spline functions that minimizes sum of squared residuals</a:t>
+            </a:r>
+          </a:p>
+          <a:p>
+            <a:pPr>
+              <a:lnSpc>
+                <a:spcPct val="90000"/>
+              </a:lnSpc>
+            </a:pPr>
+            <a:r>
+              <a:rPr lang="en-US" sz="1500" dirty="0">
+                <a:solidFill>
+                  <a:srgbClr val="FFFFFF"/>
+                </a:solidFill>
+              </a:rPr>
+              <a:t>Generalized Additive Models</a:t>
+            </a:r>
+          </a:p>
+          <a:p>
+            <a:pPr>
+              <a:lnSpc>
+                <a:spcPct val="90000"/>
+              </a:lnSpc>
+            </a:pPr>
+            <a:r>
+              <a:rPr lang="en-US" sz="1500" dirty="0">
+                <a:solidFill>
+                  <a:srgbClr val="FFFFFF"/>
+                </a:solidFill>
+              </a:rPr>
+              <a:t> Generalized Linear Models – Handles non-normal responses by combining distribution, link function, and linear predictor. </a:t>
             </a:r>
           </a:p>
           <a:p>
@@ -22736,12 +23322,12 @@
               </a:lnSpc>
             </a:pPr>
             <a:r>
-              <a:rPr lang="en-US" sz="1500">
+              <a:rPr lang="en-US" sz="1500" dirty="0">
                 <a:solidFill>
                   <a:srgbClr val="FFFFFF"/>
                 </a:solidFill>
               </a:rPr>
-              <a:t>Binomial – works for binary data</a:t>
+              <a:t>Negative Binomial – works for count data, where variance is greater than the mean</a:t>
             </a:r>
           </a:p>
           <a:p>
@@ -22751,12 +23337,12 @@
               </a:lnSpc>
             </a:pPr>
             <a:r>
-              <a:rPr lang="en-US" sz="1500">
+              <a:rPr lang="en-US" sz="1500" dirty="0">
                 <a:solidFill>
                   <a:srgbClr val="FFFFFF"/>
                 </a:solidFill>
               </a:rPr>
-              <a:t>Poisson – works for count data</a:t>
+              <a:t>Poisson – works for count data where variance is roughly equal to mean</a:t>
             </a:r>
           </a:p>
           <a:p>
@@ -22766,7 +23352,32 @@
               </a:lnSpc>
               <a:buNone/>
             </a:pPr>
-            <a:endParaRPr lang="en-US" sz="1500">
+            <a:endParaRPr lang="en-US" sz="1500" dirty="0">
+              <a:solidFill>
+                <a:srgbClr val="FFFFFF"/>
+              </a:solidFill>
+            </a:endParaRPr>
+          </a:p>
+          <a:p>
+            <a:pPr marL="457200" lvl="1" indent="0">
+              <a:lnSpc>
+                <a:spcPct val="90000"/>
+              </a:lnSpc>
+              <a:buNone/>
+            </a:pPr>
+            <a:endParaRPr lang="en-US" sz="1500" dirty="0">
+              <a:solidFill>
+                <a:srgbClr val="FFFFFF"/>
+              </a:solidFill>
+            </a:endParaRPr>
+          </a:p>
+          <a:p>
+            <a:pPr lvl="2">
+              <a:lnSpc>
+                <a:spcPct val="90000"/>
+              </a:lnSpc>
+            </a:pPr>
+            <a:endParaRPr lang="en-US" sz="1500" dirty="0">
               <a:solidFill>
                 <a:srgbClr val="FFFFFF"/>
               </a:solidFill>
@@ -22778,79 +23389,7 @@
                 <a:spcPct val="90000"/>
               </a:lnSpc>
             </a:pPr>
-            <a:r>
-              <a:rPr lang="en-US" sz="1500">
-                <a:solidFill>
-                  <a:srgbClr val="FFFFFF"/>
-                </a:solidFill>
-              </a:rPr>
-              <a:t>Generalized Linear Mixed Models for non-normal data</a:t>
-            </a:r>
-          </a:p>
-          <a:p>
-            <a:pPr lvl="1">
-              <a:lnSpc>
-                <a:spcPct val="90000"/>
-              </a:lnSpc>
-            </a:pPr>
-            <a:r>
-              <a:rPr lang="en-US" sz="1500">
-                <a:solidFill>
-                  <a:srgbClr val="FFFFFF"/>
-                </a:solidFill>
-              </a:rPr>
-              <a:t>Long format data</a:t>
-            </a:r>
-          </a:p>
-          <a:p>
-            <a:pPr lvl="1">
-              <a:lnSpc>
-                <a:spcPct val="90000"/>
-              </a:lnSpc>
-            </a:pPr>
-            <a:r>
-              <a:rPr lang="en-US" sz="1500">
-                <a:solidFill>
-                  <a:srgbClr val="FFFFFF"/>
-                </a:solidFill>
-              </a:rPr>
-              <a:t>Choose distribution, link function, random effects</a:t>
-            </a:r>
-          </a:p>
-          <a:p>
-            <a:pPr lvl="1">
-              <a:lnSpc>
-                <a:spcPct val="90000"/>
-              </a:lnSpc>
-            </a:pPr>
-            <a:r>
-              <a:rPr lang="en-US" sz="1500">
-                <a:solidFill>
-                  <a:srgbClr val="FFFFFF"/>
-                </a:solidFill>
-              </a:rPr>
-              <a:t>Fit the model</a:t>
-            </a:r>
-          </a:p>
-          <a:p>
-            <a:pPr lvl="1">
-              <a:lnSpc>
-                <a:spcPct val="90000"/>
-              </a:lnSpc>
-            </a:pPr>
-            <a:endParaRPr lang="en-US" sz="1500">
-              <a:solidFill>
-                <a:srgbClr val="FFFFFF"/>
-              </a:solidFill>
-            </a:endParaRPr>
-          </a:p>
-          <a:p>
-            <a:pPr lvl="2">
-              <a:lnSpc>
-                <a:spcPct val="90000"/>
-              </a:lnSpc>
-            </a:pPr>
-            <a:endParaRPr lang="en-US" sz="1500">
+            <a:endParaRPr lang="en-US" sz="1500" dirty="0">
               <a:solidFill>
                 <a:srgbClr val="FFFFFF"/>
               </a:solidFill>
@@ -22862,19 +23401,7 @@
                 <a:spcPct val="90000"/>
               </a:lnSpc>
             </a:pPr>
-            <a:endParaRPr lang="en-US" sz="1500">
-              <a:solidFill>
-                <a:srgbClr val="FFFFFF"/>
-              </a:solidFill>
-            </a:endParaRPr>
-          </a:p>
-          <a:p>
-            <a:pPr>
-              <a:lnSpc>
-                <a:spcPct val="90000"/>
-              </a:lnSpc>
-            </a:pPr>
-            <a:endParaRPr lang="en-US" sz="1500">
+            <a:endParaRPr lang="en-US" sz="1500" dirty="0">
               <a:solidFill>
                 <a:srgbClr val="FFFFFF"/>
               </a:solidFill>
@@ -23067,6 +23594,202 @@
 </file>
 
 <file path=ppt/slides/slide12.xml><?xml version="1.0" encoding="utf-8"?>
+<p:sld xmlns:a="http://schemas.openxmlformats.org/drawingml/2006/main" xmlns:r="http://schemas.openxmlformats.org/officeDocument/2006/relationships" xmlns:p="http://schemas.openxmlformats.org/presentationml/2006/main">
+  <p:cSld>
+    <p:spTree>
+      <p:nvGrpSpPr>
+        <p:cNvPr id="1" name=""/>
+        <p:cNvGrpSpPr/>
+        <p:nvPr/>
+      </p:nvGrpSpPr>
+      <p:grpSpPr>
+        <a:xfrm>
+          <a:off x="0" y="0"/>
+          <a:ext cx="0" cy="0"/>
+          <a:chOff x="0" y="0"/>
+          <a:chExt cx="0" cy="0"/>
+        </a:xfrm>
+      </p:grpSpPr>
+      <p:sp>
+        <p:nvSpPr>
+          <p:cNvPr id="2" name="Title 1">
+            <a:extLst>
+              <a:ext uri="{FF2B5EF4-FFF2-40B4-BE49-F238E27FC236}">
+                <a16:creationId xmlns:a16="http://schemas.microsoft.com/office/drawing/2014/main" id="{F0503464-067C-76A1-9FF0-733B23F347B9}"/>
+              </a:ext>
+            </a:extLst>
+          </p:cNvPr>
+          <p:cNvSpPr>
+            <a:spLocks noGrp="1"/>
+          </p:cNvSpPr>
+          <p:nvPr>
+            <p:ph type="title"/>
+          </p:nvPr>
+        </p:nvSpPr>
+        <p:spPr/>
+        <p:txBody>
+          <a:bodyPr/>
+          <a:lstStyle/>
+          <a:p>
+            <a:r>
+              <a:rPr lang="en-US" dirty="0"/>
+              <a:t>Generalized Linear Models</a:t>
+            </a:r>
+          </a:p>
+        </p:txBody>
+      </p:sp>
+      <p:sp>
+        <p:nvSpPr>
+          <p:cNvPr id="3" name="Content Placeholder 2">
+            <a:extLst>
+              <a:ext uri="{FF2B5EF4-FFF2-40B4-BE49-F238E27FC236}">
+                <a16:creationId xmlns:a16="http://schemas.microsoft.com/office/drawing/2014/main" id="{24253C64-05F2-D6C9-5757-4822B7ED838C}"/>
+              </a:ext>
+            </a:extLst>
+          </p:cNvPr>
+          <p:cNvSpPr>
+            <a:spLocks noGrp="1"/>
+          </p:cNvSpPr>
+          <p:nvPr>
+            <p:ph idx="1"/>
+          </p:nvPr>
+        </p:nvSpPr>
+        <p:spPr/>
+        <p:txBody>
+          <a:bodyPr/>
+          <a:lstStyle/>
+          <a:p>
+            <a:r>
+              <a:rPr lang="en-US" dirty="0"/>
+              <a:t>Using base r you can extract fitted values from your model using the predict() function, then compute the standardized residuals using </a:t>
+            </a:r>
+            <a:r>
+              <a:rPr lang="en-US" dirty="0" err="1"/>
+              <a:t>rstandard</a:t>
+            </a:r>
+            <a:r>
+              <a:rPr lang="en-US" dirty="0"/>
+              <a:t>(), lastly plot!</a:t>
+            </a:r>
+          </a:p>
+          <a:p>
+            <a:r>
+              <a:rPr lang="en-US" dirty="0"/>
+              <a:t>Dispersion test comes from the “AER” package and can only be run on </a:t>
+            </a:r>
+            <a:r>
+              <a:rPr lang="en-US" dirty="0" err="1"/>
+              <a:t>poisson</a:t>
+            </a:r>
+            <a:r>
+              <a:rPr lang="en-US" dirty="0"/>
+              <a:t> GLM. The function is </a:t>
+            </a:r>
+            <a:r>
+              <a:rPr lang="en-US" dirty="0" err="1"/>
+              <a:t>dispersiontest</a:t>
+            </a:r>
+            <a:r>
+              <a:rPr lang="en-US" dirty="0"/>
+              <a:t>().</a:t>
+            </a:r>
+          </a:p>
+          <a:p>
+            <a:r>
+              <a:rPr lang="en-US" dirty="0"/>
+              <a:t>To perform a likelihood ratio test, you can use the function </a:t>
+            </a:r>
+            <a:r>
+              <a:rPr lang="en-US" dirty="0" err="1"/>
+              <a:t>lrtest</a:t>
+            </a:r>
+            <a:r>
+              <a:rPr lang="en-US" dirty="0"/>
+              <a:t>()</a:t>
+            </a:r>
+          </a:p>
+          <a:p>
+            <a:endParaRPr lang="en-US" dirty="0"/>
+          </a:p>
+        </p:txBody>
+      </p:sp>
+      <p:sp>
+        <p:nvSpPr>
+          <p:cNvPr id="4" name="Text Placeholder 3">
+            <a:extLst>
+              <a:ext uri="{FF2B5EF4-FFF2-40B4-BE49-F238E27FC236}">
+                <a16:creationId xmlns:a16="http://schemas.microsoft.com/office/drawing/2014/main" id="{8AD718D3-7B7D-8C82-2210-884AB0E2161A}"/>
+              </a:ext>
+            </a:extLst>
+          </p:cNvPr>
+          <p:cNvSpPr>
+            <a:spLocks noGrp="1"/>
+          </p:cNvSpPr>
+          <p:nvPr>
+            <p:ph type="body" sz="half" idx="2"/>
+          </p:nvPr>
+        </p:nvSpPr>
+        <p:spPr>
+          <a:xfrm>
+            <a:off x="641259" y="3059854"/>
+            <a:ext cx="3820549" cy="2959946"/>
+          </a:xfrm>
+        </p:spPr>
+        <p:txBody>
+          <a:bodyPr/>
+          <a:lstStyle/>
+          <a:p>
+            <a:r>
+              <a:rPr lang="en-US" dirty="0"/>
+              <a:t>1) Fit both of your models </a:t>
+            </a:r>
+          </a:p>
+          <a:p>
+            <a:r>
+              <a:rPr lang="en-US" dirty="0"/>
+              <a:t>2. Choose a diagnostic Method</a:t>
+            </a:r>
+          </a:p>
+          <a:p>
+            <a:r>
+              <a:rPr lang="en-US" dirty="0"/>
+              <a:t>	a) Plot standardized deviance r	residuals vs. fitted values</a:t>
+            </a:r>
+          </a:p>
+          <a:p>
+            <a:r>
+              <a:rPr lang="en-US" dirty="0"/>
+              <a:t>	b) Check dispersion </a:t>
+            </a:r>
+          </a:p>
+          <a:p>
+            <a:r>
+              <a:rPr lang="en-US" dirty="0"/>
+              <a:t>	c) Likelihood Ratio test</a:t>
+            </a:r>
+          </a:p>
+          <a:p>
+            <a:r>
+              <a:rPr lang="en-US" dirty="0"/>
+              <a:t>3) Select model based on diagnostic methods.</a:t>
+            </a:r>
+          </a:p>
+        </p:txBody>
+      </p:sp>
+    </p:spTree>
+    <p:extLst>
+      <p:ext uri="{BB962C8B-B14F-4D97-AF65-F5344CB8AC3E}">
+        <p14:creationId xmlns:p14="http://schemas.microsoft.com/office/powerpoint/2010/main" val="78220099"/>
+      </p:ext>
+    </p:extLst>
+  </p:cSld>
+  <p:clrMapOvr>
+    <a:masterClrMapping/>
+  </p:clrMapOvr>
+</p:sld>
+</file>
+
+<file path=ppt/slides/slide13.xml><?xml version="1.0" encoding="utf-8"?>
 <p:sld xmlns:a="http://schemas.openxmlformats.org/drawingml/2006/main" xmlns:r="http://schemas.openxmlformats.org/officeDocument/2006/relationships" xmlns:p="http://schemas.openxmlformats.org/presentationml/2006/main">
   <p:cSld>
     <p:spTree>
@@ -24457,7 +25180,7 @@
 </p:sld>
 </file>
 
-<file path=ppt/slides/slide13.xml><?xml version="1.0" encoding="utf-8"?>
+<file path=ppt/slides/slide14.xml><?xml version="1.0" encoding="utf-8"?>
 <p:sld xmlns:a="http://schemas.openxmlformats.org/drawingml/2006/main" xmlns:r="http://schemas.openxmlformats.org/officeDocument/2006/relationships" xmlns:p="http://schemas.openxmlformats.org/presentationml/2006/main">
   <p:cSld>
     <p:bg>
@@ -25022,7 +25745,7 @@
 </p:sld>
 </file>
 
-<file path=ppt/slides/slide14.xml><?xml version="1.0" encoding="utf-8"?>
+<file path=ppt/slides/slide15.xml><?xml version="1.0" encoding="utf-8"?>
 <p:sld xmlns:a="http://schemas.openxmlformats.org/drawingml/2006/main" xmlns:r="http://schemas.openxmlformats.org/officeDocument/2006/relationships" xmlns:p="http://schemas.openxmlformats.org/presentationml/2006/main">
   <p:cSld>
     <p:spTree>
@@ -25054,7 +25777,7 @@
         <p:spPr>
           <a:xfrm>
             <a:off x="2371241" y="619932"/>
-            <a:ext cx="7299701" cy="4431983"/>
+            <a:ext cx="7299701" cy="5262979"/>
           </a:xfrm>
           <a:prstGeom prst="rect">
             <a:avLst/>
@@ -25114,6 +25837,21 @@
                 <a:hlinkClick r:id="rId4"/>
               </a:rPr>
               <a:t>https://www.youtube.com/watch?v=lE_HBLDnZFE</a:t>
+            </a:r>
+            <a:r>
+              <a:rPr lang="en-US" dirty="0"/>
+              <a:t> </a:t>
+            </a:r>
+          </a:p>
+          <a:p>
+            <a:endParaRPr lang="en-US" dirty="0"/>
+          </a:p>
+          <a:p>
+            <a:r>
+              <a:rPr lang="en-US" dirty="0">
+                <a:hlinkClick r:id="rId5"/>
+              </a:rPr>
+              <a:t>https://mike-data-analysis.share.connect.posit.cloud/sec-nonparametric-regression.html</a:t>
             </a:r>
             <a:r>
               <a:rPr lang="en-US" dirty="0"/>
@@ -30001,7 +30739,7 @@
           <p:nvPr/>
         </p:nvPicPr>
         <p:blipFill>
-          <a:blip r:embed="rId2"/>
+          <a:blip r:embed="rId3"/>
           <a:stretch>
             <a:fillRect/>
           </a:stretch>
@@ -30031,7 +30769,7 @@
           <p:nvPr/>
         </p:nvPicPr>
         <p:blipFill>
-          <a:blip r:embed="rId3"/>
+          <a:blip r:embed="rId4"/>
           <a:stretch>
             <a:fillRect/>
           </a:stretch>

</xml_diff>